<commit_message>
Expand explanatory text on every slide
Co-Authored-By: Claude Opus 5.5 <noreply@anthropic.com>
</commit_message>
<xml_diff>
--- a/kayin-hevel.pptx
+++ b/kayin-hevel.pptx
@@ -116,31 +116,31 @@
   <p:extLst>
     <p:ext uri="{521415D9-36F7-43E2-AB2F-B90AF26B5E84}">
       <p14:sectionLst xmlns:p14="http://schemas.microsoft.com/office/powerpoint/2010/main">
-        <p14:section name="פתיחה" id="{35daeab4-bb97-97b0-8d42-19b5e36f1a53}">
+        <p14:section name="פתיחה" id="{9f81e7c2-9dd5-23fc-59c5-5337a7e8e757}">
           <p14:sldIdLst>
             <p14:sldId id="256"/>
           </p14:sldIdLst>
         </p14:section>
-        <p14:section name="הסיפור" id="{2f693bd3-70fe-5d02-7953-0d7ea386a809}">
+        <p14:section name="הסיפור" id="{d88eda94-f70e-357a-5e5a-31ff8a2ff18b}">
           <p14:sldIdLst>
             <p14:sldId id="257"/>
             <p14:sldId id="258"/>
           </p14:sldIdLst>
         </p14:section>
-        <p14:section name="בחירה ופרשנות" id="{f25c8b68-971d-6307-d506-5eacdf1c1832}">
+        <p14:section name="בחירה ופרשנות" id="{91fb2536-d12f-05fe-0d46-3ecb8b302d61}">
           <p14:sldIdLst>
             <p14:sldId id="259"/>
             <p14:sldId id="260"/>
           </p14:sldIdLst>
         </p14:section>
-        <p14:section name="חטא ואחריות" id="{91144175-f523-6aaa-a67e-f218d863ae89}">
+        <p14:section name="חטא ואחריות" id="{d4c305cd-ff69-87e0-fa56-eaf88b36b9d5}">
           <p14:sldIdLst>
             <p14:sldId id="261"/>
             <p14:sldId id="262"/>
             <p14:sldId id="263"/>
           </p14:sldIdLst>
         </p14:section>
-        <p14:section name="פעילות וסיכום" id="{9f9a6069-e96c-8e55-9e5d-ff41d685718a}">
+        <p14:section name="פעילות וסיכום" id="{febb4682-9406-75a8-0c83-5cd28bf6598d}">
           <p14:sldIdLst>
             <p14:sldId id="264"/>
             <p14:sldId id="265"/>
@@ -2364,7 +2364,7 @@
         </p:nvSpPr>
         <p:spPr>
           <a:xfrm>
-            <a:off x="4846320" y="3977640"/>
+            <a:off x="4846320" y="4224528"/>
             <a:ext cx="3840480" cy="640080"/>
           </a:xfrm>
           <a:prstGeom prst="rect">
@@ -2408,7 +2408,43 @@
       </p:sp>
       <p:sp>
         <p:nvSpPr>
-          <p:cNvPr id="10" name="Text 0"/>
+          <p:cNvPr id="9" name="Text 6"/>
+          <p:cNvSpPr txBox="1"/>
+          <p:nvPr/>
+        </p:nvSpPr>
+        <p:spPr>
+          <a:xfrm>
+            <a:off x="4846320" y="3721608"/>
+            <a:ext cx="3840480" cy="457200"/>
+          </a:xfrm>
+          <a:prstGeom prst="rect">
+            <a:avLst/>
+          </a:prstGeom>
+          <a:noFill/>
+          <a:ln/>
+        </p:spPr>
+        <p:txBody>
+          <a:bodyPr wrap="square" lIns="0" tIns="0" rIns="0" bIns="0" rtlCol="0" anchor="t"/>
+          <a:lstStyle/>
+          <a:p>
+            <a:pPr rtl="1" algn="r" indent="0" marL="0">
+              <a:buNone/>
+            </a:pPr>
+            <a:r>
+              <a:rPr lang="he-IL" altLang="en-US" sz="1300" dirty="0">
+                <a:solidFill>
+                  <a:schemeClr val="accent3"/>
+                </a:solidFill>
+              </a:rPr>
+              <a:t>בפרק ד׳ מסופר על שני האחים הראשונים בעולם — ועל רגע אחד של בחירה ששינה הכול.‏</a:t>
+            </a:r>
+            <a:endParaRPr lang="he-IL" sz="1300" dirty="0"/>
+          </a:p>
+        </p:txBody>
+      </p:sp>
+      <p:sp>
+        <p:nvSpPr>
+          <p:cNvPr id="11" name="Text 0"/>
           <p:cNvSpPr/>
           <p:nvPr>
             <p:ph idx="100" type="title" hasCustomPrompt="1"/>
@@ -2543,7 +2579,7 @@
         </p:nvSpPr>
         <p:spPr>
           <a:xfrm>
-            <a:off x="8339328" y="1060704"/>
+            <a:off x="8339328" y="987552"/>
             <a:ext cx="347472" cy="347472"/>
           </a:xfrm>
           <a:prstGeom prst="ellipse">
@@ -2563,7 +2599,7 @@
         </p:nvSpPr>
         <p:spPr>
           <a:xfrm>
-            <a:off x="8339328" y="1060704"/>
+            <a:off x="8339328" y="987552"/>
             <a:ext cx="347472" cy="347472"/>
           </a:xfrm>
           <a:prstGeom prst="rect">
@@ -2599,8 +2635,8 @@
         </p:nvSpPr>
         <p:spPr>
           <a:xfrm>
-            <a:off x="4480560" y="1005840"/>
-            <a:ext cx="3749040" cy="457200"/>
+            <a:off x="4480560" y="914400"/>
+            <a:ext cx="3749040" cy="530352"/>
           </a:xfrm>
           <a:prstGeom prst="rect">
             <a:avLst/>
@@ -2616,14 +2652,28 @@
               <a:buNone/>
             </a:pPr>
             <a:r>
-              <a:rPr lang="he-IL" altLang="en-US" sz="1800" b="1" dirty="0">
+              <a:rPr lang="he-IL" altLang="en-US" sz="1700" b="1" dirty="0">
                 <a:solidFill>
                   <a:schemeClr val="bg1"/>
                 </a:solidFill>
               </a:rPr>
               <a:t>רגשות קשים הם אנושיים</a:t>
             </a:r>
-            <a:endParaRPr lang="he-IL" sz="1800" dirty="0"/>
+            <a:endParaRPr lang="he-IL" sz="1700" dirty="0"/>
+          </a:p>
+          <a:p>
+            <a:pPr rtl="1" algn="r" indent="0" marL="0">
+              <a:buNone/>
+            </a:pPr>
+            <a:r>
+              <a:rPr lang="he-IL" altLang="en-US" sz="1200" dirty="0">
+                <a:solidFill>
+                  <a:schemeClr val="accent3"/>
+                </a:solidFill>
+              </a:rPr>
+              <a:t>קנאה וכעס הם טבעיים — גם לקין היו</a:t>
+            </a:r>
+            <a:endParaRPr lang="he-IL" sz="1700" dirty="0"/>
           </a:p>
         </p:txBody>
       </p:sp>
@@ -2635,7 +2685,7 @@
         </p:nvSpPr>
         <p:spPr>
           <a:xfrm>
-            <a:off x="8339328" y="1563624"/>
+            <a:off x="8339328" y="1554480"/>
             <a:ext cx="347472" cy="347472"/>
           </a:xfrm>
           <a:prstGeom prst="ellipse">
@@ -2655,7 +2705,7 @@
         </p:nvSpPr>
         <p:spPr>
           <a:xfrm>
-            <a:off x="8339328" y="1563624"/>
+            <a:off x="8339328" y="1554480"/>
             <a:ext cx="347472" cy="347472"/>
           </a:xfrm>
           <a:prstGeom prst="rect">
@@ -2691,8 +2741,8 @@
         </p:nvSpPr>
         <p:spPr>
           <a:xfrm>
-            <a:off x="4480560" y="1508760"/>
-            <a:ext cx="3749040" cy="457200"/>
+            <a:off x="4480560" y="1481328"/>
+            <a:ext cx="3749040" cy="530352"/>
           </a:xfrm>
           <a:prstGeom prst="rect">
             <a:avLst/>
@@ -2708,14 +2758,28 @@
               <a:buNone/>
             </a:pPr>
             <a:r>
-              <a:rPr lang="he-IL" altLang="en-US" sz="1800" b="1" dirty="0">
+              <a:rPr lang="he-IL" altLang="en-US" sz="1700" b="1" dirty="0">
                 <a:solidFill>
                   <a:schemeClr val="bg1"/>
                 </a:solidFill>
               </a:rPr>
               <a:t>המעשים הם בחירה</a:t>
             </a:r>
-            <a:endParaRPr lang="he-IL" sz="1800" dirty="0"/>
+            <a:endParaRPr lang="he-IL" sz="1700" dirty="0"/>
+          </a:p>
+          <a:p>
+            <a:pPr rtl="1" algn="r" indent="0" marL="0">
+              <a:buNone/>
+            </a:pPr>
+            <a:r>
+              <a:rPr lang="he-IL" altLang="en-US" sz="1200" dirty="0">
+                <a:solidFill>
+                  <a:schemeClr val="accent3"/>
+                </a:solidFill>
+              </a:rPr>
+              <a:t>‏„וְאַתָּה תִּמְשָׁל־בּוֹ” — אם תרצה, תתגבר</a:t>
+            </a:r>
+            <a:endParaRPr lang="he-IL" sz="1700" dirty="0"/>
           </a:p>
         </p:txBody>
       </p:sp>
@@ -2727,7 +2791,7 @@
         </p:nvSpPr>
         <p:spPr>
           <a:xfrm>
-            <a:off x="8339328" y="2066544"/>
+            <a:off x="8339328" y="2121408"/>
             <a:ext cx="347472" cy="347472"/>
           </a:xfrm>
           <a:prstGeom prst="ellipse">
@@ -2747,7 +2811,7 @@
         </p:nvSpPr>
         <p:spPr>
           <a:xfrm>
-            <a:off x="8339328" y="2066544"/>
+            <a:off x="8339328" y="2121408"/>
             <a:ext cx="347472" cy="347472"/>
           </a:xfrm>
           <a:prstGeom prst="rect">
@@ -2783,8 +2847,8 @@
         </p:nvSpPr>
         <p:spPr>
           <a:xfrm>
-            <a:off x="4480560" y="2011680"/>
-            <a:ext cx="3749040" cy="457200"/>
+            <a:off x="4480560" y="2048256"/>
+            <a:ext cx="3749040" cy="530352"/>
           </a:xfrm>
           <a:prstGeom prst="rect">
             <a:avLst/>
@@ -2800,14 +2864,28 @@
               <a:buNone/>
             </a:pPr>
             <a:r>
-              <a:rPr lang="he-IL" altLang="en-US" sz="1800" b="1" dirty="0">
+              <a:rPr lang="he-IL" altLang="en-US" sz="1700" b="1" dirty="0">
                 <a:solidFill>
                   <a:schemeClr val="bg1"/>
                 </a:solidFill>
               </a:rPr>
               <a:t>לוקחים אחריות — מודים ולא בורחים</a:t>
             </a:r>
-            <a:endParaRPr lang="he-IL" sz="1800" dirty="0"/>
+            <a:endParaRPr lang="he-IL" sz="1700" dirty="0"/>
+          </a:p>
+          <a:p>
+            <a:pPr rtl="1" algn="r" indent="0" marL="0">
+              <a:buNone/>
+            </a:pPr>
+            <a:r>
+              <a:rPr lang="he-IL" altLang="en-US" sz="1200" dirty="0">
+                <a:solidFill>
+                  <a:schemeClr val="accent3"/>
+                </a:solidFill>
+              </a:rPr>
+              <a:t>להודות, להתחרט ולתקן, כמו יהודה ודוד</a:t>
+            </a:r>
+            <a:endParaRPr lang="he-IL" sz="1700" dirty="0"/>
           </a:p>
         </p:txBody>
       </p:sp>
@@ -2819,12 +2897,12 @@
         </p:nvSpPr>
         <p:spPr>
           <a:xfrm>
-            <a:off x="4572000" y="2606040"/>
-            <a:ext cx="4114800" cy="731520"/>
+            <a:off x="4572000" y="2697480"/>
+            <a:ext cx="4114800" cy="621792"/>
           </a:xfrm>
           <a:prstGeom prst="roundRect">
             <a:avLst>
-              <a:gd name="adj" fmla="val 12500"/>
+              <a:gd name="adj" fmla="val 14706"/>
             </a:avLst>
           </a:prstGeom>
           <a:solidFill>
@@ -2846,8 +2924,8 @@
         </p:nvSpPr>
         <p:spPr>
           <a:xfrm>
-            <a:off x="4709160" y="2606040"/>
-            <a:ext cx="3840480" cy="731520"/>
+            <a:off x="4709160" y="2697480"/>
+            <a:ext cx="3840480" cy="621792"/>
           </a:xfrm>
           <a:prstGeom prst="rect">
             <a:avLst/>
@@ -2941,7 +3019,7 @@
                   <a:schemeClr val="accent3"/>
                 </a:solidFill>
               </a:rPr>
-              <a:t>רש״י על בראשית ד׳, ג׳ („מן הגרוע”) ועל ד׳, ז׳ („אם תרצה תתגבר עליו”)‏</a:t>
+              <a:t>רש״י על בראשית ד׳, ג׳ („מן הגרוע”) ועל ד׳, ז׳ („אם תרצה תתגבר עליו”)‏</a:t>
             </a:r>
             <a:endParaRPr lang="he-IL" sz="1050" dirty="0"/>
           </a:p>
@@ -3141,14 +3219,13 @@
         </p:nvPicPr>
         <p:blipFill>
           <a:blip r:embed="rId1"/>
-          <a:stretch>
-            <a:fillRect/>
-          </a:stretch>
+          <a:srcRect l="0" r="0" t="0" b="0"/>
+          <a:stretch/>
         </p:blipFill>
         <p:spPr>
           <a:xfrm>
             <a:off x="457200" y="1051560"/>
-            <a:ext cx="3108960" cy="3602736"/>
+            <a:ext cx="3017520" cy="3602736"/>
           </a:xfrm>
           <a:prstGeom prst="rect">
             <a:avLst/>
@@ -3247,8 +3324,8 @@
         </p:nvSpPr>
         <p:spPr>
           <a:xfrm>
-            <a:off x="3931920" y="1078992"/>
-            <a:ext cx="4297680" cy="548640"/>
+            <a:off x="3749040" y="1078992"/>
+            <a:ext cx="4480560" cy="548640"/>
           </a:xfrm>
           <a:prstGeom prst="rect">
             <a:avLst/>
@@ -3278,12 +3355,12 @@
               <a:buNone/>
             </a:pPr>
             <a:r>
-              <a:rPr lang="he-IL" altLang="en-US" sz="1100" dirty="0">
+              <a:rPr lang="he-IL" altLang="en-US" sz="1150" dirty="0">
                 <a:solidFill>
                   <a:schemeClr val="accent6"/>
                 </a:solidFill>
               </a:rPr>
-              <a:t>בראשית ד׳, ב׳</a:t>
+              <a:t>שני עיסוקים שונים, שתי דרכים לפרנס את העולם · ד׳, ב׳</a:t>
             </a:r>
             <a:endParaRPr lang="he-IL" sz="1500" dirty="0"/>
           </a:p>
@@ -3358,8 +3435,8 @@
         </p:nvSpPr>
         <p:spPr>
           <a:xfrm>
-            <a:off x="3931920" y="1664208"/>
-            <a:ext cx="4297680" cy="548640"/>
+            <a:off x="3749040" y="1664208"/>
+            <a:ext cx="4480560" cy="548640"/>
           </a:xfrm>
           <a:prstGeom prst="rect">
             <a:avLst/>
@@ -3389,12 +3466,12 @@
               <a:buNone/>
             </a:pPr>
             <a:r>
-              <a:rPr lang="he-IL" altLang="en-US" sz="1100" dirty="0">
+              <a:rPr lang="he-IL" altLang="en-US" sz="1150" dirty="0">
                 <a:solidFill>
                   <a:schemeClr val="accent6"/>
                 </a:solidFill>
               </a:rPr>
-              <a:t>בראשית ד׳, ג׳–ד׳</a:t>
+              <a:t>קין „מִפְּרִי הָאֲדָמָה”, הבל „מִבְּכֹרוֹת צֹאנוֹ” · ד׳, ג׳–ד׳</a:t>
             </a:r>
             <a:endParaRPr lang="he-IL" sz="1500" dirty="0"/>
           </a:p>
@@ -3469,8 +3546,8 @@
         </p:nvSpPr>
         <p:spPr>
           <a:xfrm>
-            <a:off x="3931920" y="2249424"/>
-            <a:ext cx="4297680" cy="548640"/>
+            <a:off x="3749040" y="2249424"/>
+            <a:ext cx="4480560" cy="548640"/>
           </a:xfrm>
           <a:prstGeom prst="rect">
             <a:avLst/>
@@ -3500,12 +3577,12 @@
               <a:buNone/>
             </a:pPr>
             <a:r>
-              <a:rPr lang="he-IL" altLang="en-US" sz="1100" dirty="0">
+              <a:rPr lang="he-IL" altLang="en-US" sz="1150" dirty="0">
                 <a:solidFill>
                   <a:schemeClr val="accent6"/>
                 </a:solidFill>
               </a:rPr>
-              <a:t>בראשית ד׳, ד׳–ה׳</a:t>
+              <a:t>הפסוק לא מסביר למה — וכאן מתחילה הפרשנות · ד׳, ד׳–ה׳</a:t>
             </a:r>
             <a:endParaRPr lang="he-IL" sz="1500" dirty="0"/>
           </a:p>
@@ -3580,8 +3657,8 @@
         </p:nvSpPr>
         <p:spPr>
           <a:xfrm>
-            <a:off x="3931920" y="2834640"/>
-            <a:ext cx="4297680" cy="548640"/>
+            <a:off x="3749040" y="2834640"/>
+            <a:ext cx="4480560" cy="548640"/>
           </a:xfrm>
           <a:prstGeom prst="rect">
             <a:avLst/>
@@ -3611,12 +3688,12 @@
               <a:buNone/>
             </a:pPr>
             <a:r>
-              <a:rPr lang="he-IL" altLang="en-US" sz="1100" dirty="0">
+              <a:rPr lang="he-IL" altLang="en-US" sz="1150" dirty="0">
                 <a:solidFill>
                   <a:schemeClr val="accent6"/>
                 </a:solidFill>
               </a:rPr>
-              <a:t>בראשית ד׳, ה׳</a:t>
+              <a:t>אכזבה שהופכת לכעס ולקנאה באח · ד׳, ה׳</a:t>
             </a:r>
             <a:endParaRPr lang="he-IL" sz="1500" dirty="0"/>
           </a:p>
@@ -3691,8 +3768,8 @@
         </p:nvSpPr>
         <p:spPr>
           <a:xfrm>
-            <a:off x="3931920" y="3419856"/>
-            <a:ext cx="4297680" cy="548640"/>
+            <a:off x="3749040" y="3419856"/>
+            <a:ext cx="4480560" cy="548640"/>
           </a:xfrm>
           <a:prstGeom prst="rect">
             <a:avLst/>
@@ -3722,12 +3799,12 @@
               <a:buNone/>
             </a:pPr>
             <a:r>
-              <a:rPr lang="he-IL" altLang="en-US" sz="1100" dirty="0">
+              <a:rPr lang="he-IL" altLang="en-US" sz="1150" dirty="0">
                 <a:solidFill>
                   <a:schemeClr val="accent6"/>
                 </a:solidFill>
               </a:rPr>
-              <a:t>בראשית ד׳, ו׳–ז׳</a:t>
+              <a:t>ה׳ מזהיר: החטא מחכה בפתח, אבל אתה יכול לשלוט בו · ד׳, ו׳–ז׳</a:t>
             </a:r>
             <a:endParaRPr lang="he-IL" sz="1500" dirty="0"/>
           </a:p>
@@ -3802,8 +3879,8 @@
         </p:nvSpPr>
         <p:spPr>
           <a:xfrm>
-            <a:off x="3931920" y="4005072"/>
-            <a:ext cx="4297680" cy="548640"/>
+            <a:off x="3749040" y="4005072"/>
+            <a:ext cx="4480560" cy="548640"/>
           </a:xfrm>
           <a:prstGeom prst="rect">
             <a:avLst/>
@@ -3833,12 +3910,12 @@
               <a:buNone/>
             </a:pPr>
             <a:r>
-              <a:rPr lang="he-IL" altLang="en-US" sz="1100" dirty="0">
+              <a:rPr lang="he-IL" altLang="en-US" sz="1150" dirty="0">
                 <a:solidFill>
                   <a:schemeClr val="accent6"/>
                 </a:solidFill>
               </a:rPr>
-              <a:t>בראשית ד׳, ח׳</a:t>
+              <a:t>הבחירה הרעה הופכת למעשה שאי אפשר להחזיר · ד׳, ח׳</a:t>
             </a:r>
             <a:endParaRPr lang="he-IL" sz="1500" dirty="0"/>
           </a:p>
@@ -4349,8 +4426,8 @@
         </p:nvSpPr>
         <p:spPr>
           <a:xfrm>
-            <a:off x="1988820" y="2048256"/>
-            <a:ext cx="1691640" cy="274320"/>
+            <a:off x="7178040" y="2057400"/>
+            <a:ext cx="1600200" cy="274320"/>
           </a:xfrm>
           <a:prstGeom prst="rect">
             <a:avLst/>
@@ -4366,12 +4443,165 @@
               <a:buNone/>
             </a:pPr>
             <a:r>
+              <a:rPr lang="he-IL" altLang="en-US" sz="1100" dirty="0">
+                <a:solidFill>
+                  <a:schemeClr val="accent6"/>
+                </a:solidFill>
+              </a:rPr>
+              <a:t>המנחה לא התקבלה</a:t>
+            </a:r>
+            <a:endParaRPr lang="he-IL" sz="1100" dirty="0"/>
+          </a:p>
+        </p:txBody>
+      </p:sp>
+      <p:sp>
+        <p:nvSpPr>
+          <p:cNvPr id="18" name="Text 16"/>
+          <p:cNvSpPr txBox="1"/>
+          <p:nvPr/>
+        </p:nvSpPr>
+        <p:spPr>
+          <a:xfrm>
+            <a:off x="5463540" y="2057400"/>
+            <a:ext cx="1600200" cy="274320"/>
+          </a:xfrm>
+          <a:prstGeom prst="rect">
+            <a:avLst/>
+          </a:prstGeom>
+          <a:noFill/>
+          <a:ln/>
+        </p:spPr>
+        <p:txBody>
+          <a:bodyPr wrap="square" lIns="0" tIns="0" rIns="0" bIns="0" rtlCol="0" anchor="ctr"/>
+          <a:lstStyle/>
+          <a:p>
+            <a:pPr rtl="1" algn="ctr" indent="0" marL="0">
+              <a:buNone/>
+            </a:pPr>
+            <a:r>
+              <a:rPr lang="he-IL" altLang="en-US" sz="1100" dirty="0">
+                <a:solidFill>
+                  <a:schemeClr val="accent6"/>
+                </a:solidFill>
+                <a:latin typeface="Times New Roman" pitchFamily="34" charset="0"/>
+                <a:ea typeface="Times New Roman" pitchFamily="34" charset="-122"/>
+                <a:cs typeface="Times New Roman" pitchFamily="34" charset="-120"/>
+              </a:rPr>
+              <a:t>‏„וַיִּחַר לְקַיִן מְאֹד”‏</a:t>
+            </a:r>
+            <a:endParaRPr lang="he-IL" sz="1100" dirty="0"/>
+          </a:p>
+        </p:txBody>
+      </p:sp>
+      <p:sp>
+        <p:nvSpPr>
+          <p:cNvPr id="19" name="Text 17"/>
+          <p:cNvSpPr txBox="1"/>
+          <p:nvPr/>
+        </p:nvSpPr>
+        <p:spPr>
+          <a:xfrm>
+            <a:off x="3749040" y="2057400"/>
+            <a:ext cx="1600200" cy="274320"/>
+          </a:xfrm>
+          <a:prstGeom prst="rect">
+            <a:avLst/>
+          </a:prstGeom>
+          <a:noFill/>
+          <a:ln/>
+        </p:spPr>
+        <p:txBody>
+          <a:bodyPr wrap="square" lIns="0" tIns="0" rIns="0" bIns="0" rtlCol="0" anchor="ctr"/>
+          <a:lstStyle/>
+          <a:p>
+            <a:pPr rtl="1" algn="ctr" indent="0" marL="0">
+              <a:buNone/>
+            </a:pPr>
+            <a:r>
+              <a:rPr lang="he-IL" altLang="en-US" sz="1100" dirty="0">
+                <a:solidFill>
+                  <a:schemeClr val="accent6"/>
+                </a:solidFill>
+                <a:latin typeface="Times New Roman" pitchFamily="34" charset="0"/>
+                <a:ea typeface="Times New Roman" pitchFamily="34" charset="-122"/>
+                <a:cs typeface="Times New Roman" pitchFamily="34" charset="-120"/>
+              </a:rPr>
+              <a:t>‏„וַיִּפְּלוּ פָּנָיו”‏</a:t>
+            </a:r>
+            <a:endParaRPr lang="he-IL" sz="1100" dirty="0"/>
+          </a:p>
+        </p:txBody>
+      </p:sp>
+      <p:sp>
+        <p:nvSpPr>
+          <p:cNvPr id="20" name="Text 18"/>
+          <p:cNvSpPr txBox="1"/>
+          <p:nvPr/>
+        </p:nvSpPr>
+        <p:spPr>
+          <a:xfrm>
+            <a:off x="2034540" y="2057400"/>
+            <a:ext cx="1600200" cy="274320"/>
+          </a:xfrm>
+          <a:prstGeom prst="rect">
+            <a:avLst/>
+          </a:prstGeom>
+          <a:noFill/>
+          <a:ln/>
+        </p:spPr>
+        <p:txBody>
+          <a:bodyPr wrap="square" lIns="0" tIns="0" rIns="0" bIns="0" rtlCol="0" anchor="ctr"/>
+          <a:lstStyle/>
+          <a:p>
+            <a:pPr rtl="1" algn="ctr" indent="0" marL="0">
+              <a:buNone/>
+            </a:pPr>
+            <a:r>
               <a:rPr lang="he-IL" altLang="en-US" sz="1100" b="1" dirty="0">
                 <a:solidFill>
                   <a:schemeClr val="accent1"/>
                 </a:solidFill>
               </a:rPr>
-              <a:t>כאן נמצאת נקודת ההכרעה</a:t>
+              <a:t>כאן אפשר לעצור</a:t>
+            </a:r>
+            <a:endParaRPr lang="he-IL" sz="1100" dirty="0"/>
+          </a:p>
+        </p:txBody>
+      </p:sp>
+      <p:sp>
+        <p:nvSpPr>
+          <p:cNvPr id="21" name="Text 19"/>
+          <p:cNvSpPr txBox="1"/>
+          <p:nvPr/>
+        </p:nvSpPr>
+        <p:spPr>
+          <a:xfrm>
+            <a:off x="320040" y="2057400"/>
+            <a:ext cx="1600200" cy="274320"/>
+          </a:xfrm>
+          <a:prstGeom prst="rect">
+            <a:avLst/>
+          </a:prstGeom>
+          <a:noFill/>
+          <a:ln/>
+        </p:spPr>
+        <p:txBody>
+          <a:bodyPr wrap="square" lIns="0" tIns="0" rIns="0" bIns="0" rtlCol="0" anchor="ctr"/>
+          <a:lstStyle/>
+          <a:p>
+            <a:pPr rtl="1" algn="ctr" indent="0" marL="0">
+              <a:buNone/>
+            </a:pPr>
+            <a:r>
+              <a:rPr lang="he-IL" altLang="en-US" sz="1100" dirty="0">
+                <a:solidFill>
+                  <a:schemeClr val="accent6"/>
+                </a:solidFill>
+                <a:latin typeface="Times New Roman" pitchFamily="34" charset="0"/>
+                <a:ea typeface="Times New Roman" pitchFamily="34" charset="-122"/>
+                <a:cs typeface="Times New Roman" pitchFamily="34" charset="-120"/>
+              </a:rPr>
+              <a:t>‏„וַיָּקָם קַיִן”‏</a:t>
             </a:r>
             <a:endParaRPr lang="he-IL" sz="1100" dirty="0"/>
           </a:p>
@@ -4379,7 +4609,7 @@
       </p:sp>
       <p:pic>
         <p:nvPicPr>
-          <p:cNvPr id="18" name="Illustration" descr="איור: מאזניים זהובים — בכף אחת ענן ובכף השנייה שמש, סמל להתלבטות">    </p:cNvPr>
+          <p:cNvPr id="22" name="Illustration" descr="איור: מאזניים זהובים — בכף אחת ענן ובכף השנייה שמש, סמל להתלבטות">    </p:cNvPr>
           <p:cNvPicPr>
             <a:picLocks noChangeAspect="1"/>
           </p:cNvPicPr>
@@ -4403,7 +4633,7 @@
       </p:pic>
       <p:sp>
         <p:nvSpPr>
-          <p:cNvPr id="19" name="Key idea box"/>
+          <p:cNvPr id="23" name="Key idea box"/>
           <p:cNvSpPr/>
           <p:nvPr/>
         </p:nvSpPr>
@@ -4425,64 +4655,100 @@
       </p:sp>
       <p:sp>
         <p:nvSpPr>
-          <p:cNvPr id="20" name="Text 17"/>
+          <p:cNvPr id="24" name="Text 21"/>
           <p:cNvSpPr txBox="1"/>
           <p:nvPr/>
         </p:nvSpPr>
         <p:spPr>
           <a:xfrm>
-            <a:off x="4297680" y="2651760"/>
-            <a:ext cx="4114800" cy="1143000"/>
-          </a:xfrm>
-          <a:prstGeom prst="rect">
-            <a:avLst/>
-          </a:prstGeom>
-          <a:noFill/>
-          <a:ln/>
-        </p:spPr>
-        <p:txBody>
-          <a:bodyPr wrap="square" lIns="0" tIns="0" rIns="0" bIns="0" rtlCol="0" anchor="ctr"/>
-          <a:lstStyle/>
-          <a:p>
-            <a:pPr rtl="1" algn="r" indent="0" marL="0">
-              <a:buNone/>
-            </a:pPr>
-            <a:r>
-              <a:rPr lang="he-IL" altLang="en-US" sz="2000" b="1" dirty="0">
+            <a:off x="4251960" y="2633472"/>
+            <a:ext cx="4206240" cy="658368"/>
+          </a:xfrm>
+          <a:prstGeom prst="rect">
+            <a:avLst/>
+          </a:prstGeom>
+          <a:noFill/>
+          <a:ln/>
+        </p:spPr>
+        <p:txBody>
+          <a:bodyPr wrap="square" lIns="0" tIns="0" rIns="0" bIns="0" rtlCol="0" anchor="t"/>
+          <a:lstStyle/>
+          <a:p>
+            <a:pPr rtl="1" algn="r" indent="0" marL="0">
+              <a:buNone/>
+            </a:pPr>
+            <a:r>
+              <a:rPr lang="he-IL" altLang="en-US" sz="1800" b="1" dirty="0">
                 <a:solidFill>
                   <a:schemeClr val="bg1"/>
                 </a:solidFill>
               </a:rPr>
               <a:t>רגש הוא לא בהכרח בחירה —‏</a:t>
             </a:r>
-            <a:endParaRPr lang="he-IL" sz="2000" dirty="0"/>
-          </a:p>
-          <a:p>
-            <a:pPr rtl="1" algn="r" indent="0" marL="0">
-              <a:buNone/>
-            </a:pPr>
-            <a:r>
-              <a:rPr lang="he-IL" altLang="en-US" sz="2000" b="1" dirty="0">
+            <a:endParaRPr lang="he-IL" sz="1800" dirty="0"/>
+          </a:p>
+          <a:p>
+            <a:pPr rtl="1" algn="r" indent="0" marL="0">
+              <a:buNone/>
+            </a:pPr>
+            <a:r>
+              <a:rPr lang="he-IL" altLang="en-US" sz="1800" b="1" dirty="0">
                 <a:solidFill>
                   <a:schemeClr val="accent1"/>
                 </a:solidFill>
               </a:rPr>
               <a:t>אבל התגובה לרגש יכולה להיות בחירה.‏</a:t>
             </a:r>
-            <a:endParaRPr lang="he-IL" sz="2000" dirty="0"/>
-          </a:p>
-        </p:txBody>
-      </p:sp>
-      <p:sp>
-        <p:nvSpPr>
-          <p:cNvPr id="21" name="Text 18"/>
+            <a:endParaRPr lang="he-IL" sz="1800" dirty="0"/>
+          </a:p>
+        </p:txBody>
+      </p:sp>
+      <p:sp>
+        <p:nvSpPr>
+          <p:cNvPr id="25" name="Text 22"/>
           <p:cNvSpPr txBox="1"/>
           <p:nvPr/>
         </p:nvSpPr>
         <p:spPr>
           <a:xfrm>
-            <a:off x="4297680" y="3840480"/>
-            <a:ext cx="4114800" cy="685800"/>
+            <a:off x="4251960" y="3310128"/>
+            <a:ext cx="4206240" cy="603504"/>
+          </a:xfrm>
+          <a:prstGeom prst="rect">
+            <a:avLst/>
+          </a:prstGeom>
+          <a:noFill/>
+          <a:ln/>
+        </p:spPr>
+        <p:txBody>
+          <a:bodyPr wrap="square" lIns="0" tIns="0" rIns="0" bIns="0" rtlCol="0" anchor="t"/>
+          <a:lstStyle/>
+          <a:p>
+            <a:pPr rtl="1" algn="r" indent="0" marL="0">
+              <a:buNone/>
+            </a:pPr>
+            <a:r>
+              <a:rPr lang="he-IL" altLang="en-US" sz="1400" dirty="0">
+                <a:solidFill>
+                  <a:schemeClr val="bg1"/>
+                </a:solidFill>
+              </a:rPr>
+              <a:t>ה׳ לא מאשים את קין על הכעס. הוא שואל אותו עליו — ומזמין אותו לעצור ולחשוב לפני שהוא פועל.‏</a:t>
+            </a:r>
+            <a:endParaRPr lang="he-IL" sz="1400" dirty="0"/>
+          </a:p>
+        </p:txBody>
+      </p:sp>
+      <p:sp>
+        <p:nvSpPr>
+          <p:cNvPr id="26" name="Text 23"/>
+          <p:cNvSpPr txBox="1"/>
+          <p:nvPr/>
+        </p:nvSpPr>
+        <p:spPr>
+          <a:xfrm>
+            <a:off x="4251960" y="4005072"/>
+            <a:ext cx="4206240" cy="566928"/>
           </a:xfrm>
           <a:prstGeom prst="rect">
             <a:avLst/>
@@ -4506,7 +4772,7 @@
                 <a:ea typeface="Times New Roman" pitchFamily="34" charset="-122"/>
                 <a:cs typeface="Times New Roman" pitchFamily="34" charset="-120"/>
               </a:rPr>
-              <a:t>ה׳ שואל את קין: „לָמָּה חָרָה לָךְ וְלָמָּה נָפְלוּ פָנֶיךָ”‏</a:t>
+              <a:t>‏„לָמָּה חָרָה לָךְ וְלָמָּה נָפְלוּ פָנֶיךָ”‏</a:t>
             </a:r>
             <a:endParaRPr lang="he-IL" sz="1400" dirty="0"/>
           </a:p>
@@ -4682,7 +4948,7 @@
         <p:spPr>
           <a:xfrm>
             <a:off x="3931920" y="1051560"/>
-            <a:ext cx="4754880" cy="1463040"/>
+            <a:ext cx="4754880" cy="1280160"/>
           </a:xfrm>
           <a:prstGeom prst="rect">
             <a:avLst/>
@@ -4696,12 +4962,12 @@
           <a:p>
             <a:pPr rtl="1" algn="r" indent="0" marL="0">
               <a:spcAft>
-                <a:spcPts val="600"/>
+                <a:spcPts val="400"/>
               </a:spcAft>
               <a:buNone/>
             </a:pPr>
             <a:r>
-              <a:rPr lang="he-IL" altLang="en-US" sz="2100" dirty="0">
+              <a:rPr lang="he-IL" altLang="en-US" sz="1900" dirty="0">
                 <a:solidFill>
                   <a:schemeClr val="bg1"/>
                 </a:solidFill>
@@ -4711,12 +4977,12 @@
               </a:rPr>
               <a:t>‏„הֲלוֹא אִם־תֵּיטִיב שְׂאֵת וְאִם לֹא תֵיטִיב לַפֶּתַח חַטָּאת רֹבֵץ וְאֵלֶיךָ תְּשׁוּקָתוֹ וְאַתָּה תִּמְשָׁל־בּוֹ”‏</a:t>
             </a:r>
-            <a:endParaRPr lang="he-IL" sz="2100" dirty="0"/>
+            <a:endParaRPr lang="he-IL" sz="1900" dirty="0"/>
           </a:p>
           <a:p>
             <a:pPr rtl="1" algn="r" indent="0" marL="0">
               <a:spcAft>
-                <a:spcPts val="600"/>
+                <a:spcPts val="400"/>
               </a:spcAft>
               <a:buNone/>
             </a:pPr>
@@ -4728,7 +4994,7 @@
               </a:rPr>
               <a:t>בראשית ד׳, ז׳</a:t>
             </a:r>
-            <a:endParaRPr lang="he-IL" sz="2100" dirty="0"/>
+            <a:endParaRPr lang="he-IL" sz="1900" dirty="0"/>
           </a:p>
         </p:txBody>
       </p:sp>
@@ -4740,12 +5006,12 @@
         </p:nvSpPr>
         <p:spPr>
           <a:xfrm>
-            <a:off x="3931920" y="2651760"/>
-            <a:ext cx="4754880" cy="868680"/>
+            <a:off x="3931920" y="2423160"/>
+            <a:ext cx="4754880" cy="1280160"/>
           </a:xfrm>
           <a:prstGeom prst="roundRect">
             <a:avLst>
-              <a:gd name="adj" fmla="val 10526"/>
+              <a:gd name="adj" fmla="val 7143"/>
             </a:avLst>
           </a:prstGeom>
           <a:solidFill>
@@ -4767,8 +5033,8 @@
         </p:nvSpPr>
         <p:spPr>
           <a:xfrm>
-            <a:off x="4114800" y="2651760"/>
-            <a:ext cx="4434840" cy="868680"/>
+            <a:off x="4114800" y="2487168"/>
+            <a:ext cx="4434840" cy="1152144"/>
           </a:xfrm>
           <a:prstGeom prst="rect">
             <a:avLst/>
@@ -4781,31 +5047,82 @@
           <a:lstStyle/>
           <a:p>
             <a:pPr rtl="1" algn="r" indent="0" marL="0">
-              <a:buNone/>
-            </a:pPr>
-            <a:r>
-              <a:rPr lang="he-IL" altLang="en-US" sz="1800" b="1" dirty="0">
+              <a:spcAft>
+                <a:spcPts val="400"/>
+              </a:spcAft>
+              <a:buNone/>
+            </a:pPr>
+            <a:r>
+              <a:rPr lang="he-IL" altLang="en-US" sz="1100" dirty="0">
+                <a:solidFill>
+                  <a:schemeClr val="accent3"/>
+                </a:solidFill>
+              </a:rPr>
+              <a:t>רש״י על בראשית ד׳, ז׳</a:t>
+            </a:r>
+            <a:endParaRPr lang="he-IL" sz="1100" dirty="0"/>
+          </a:p>
+          <a:p>
+            <a:pPr rtl="1" algn="r" indent="0" marL="0">
+              <a:spcAft>
+                <a:spcPts val="400"/>
+              </a:spcAft>
+              <a:buNone/>
+            </a:pPr>
+            <a:r>
+              <a:rPr lang="he-IL" altLang="en-US" sz="1400" b="1" dirty="0">
                 <a:solidFill>
                   <a:schemeClr val="accent1"/>
                 </a:solidFill>
               </a:rPr>
-              <a:t>רש״י: „אם תרצה — תתגבר עליו”‏</a:t>
-            </a:r>
-            <a:endParaRPr lang="he-IL" sz="1800" dirty="0"/>
-          </a:p>
-          <a:p>
-            <a:pPr rtl="1" algn="r" indent="0" marL="0">
-              <a:buNone/>
-            </a:pPr>
-            <a:r>
-              <a:rPr lang="he-IL" altLang="en-US" sz="1100" dirty="0">
-                <a:solidFill>
-                  <a:schemeClr val="accent3"/>
-                </a:solidFill>
-              </a:rPr>
-              <a:t>רש״י על בראשית ד׳, ז׳</a:t>
-            </a:r>
-            <a:endParaRPr lang="he-IL" sz="1800" dirty="0"/>
+              <a:t>‏„ואליך תשוקתו” — ‏</a:t>
+            </a:r>
+            <a:pPr rtl="1" algn="r" indent="0" marL="0">
+              <a:spcAft>
+                <a:spcPts val="400"/>
+              </a:spcAft>
+              <a:buNone/>
+            </a:pPr>
+            <a:r>
+              <a:rPr lang="he-IL" altLang="en-US" sz="1400" dirty="0">
+                <a:solidFill>
+                  <a:schemeClr val="bg1"/>
+                </a:solidFill>
+              </a:rPr>
+              <a:t>יצר הרע „תמיד שוקק ומתאווה להכשילך”‏</a:t>
+            </a:r>
+            <a:endParaRPr lang="he-IL" sz="1100" dirty="0"/>
+          </a:p>
+          <a:p>
+            <a:pPr rtl="1" algn="r" indent="0" marL="0">
+              <a:spcAft>
+                <a:spcPts val="400"/>
+              </a:spcAft>
+              <a:buNone/>
+            </a:pPr>
+            <a:r>
+              <a:rPr lang="he-IL" altLang="en-US" sz="1400" b="1" dirty="0">
+                <a:solidFill>
+                  <a:schemeClr val="accent1"/>
+                </a:solidFill>
+              </a:rPr>
+              <a:t>‏„ואתה תמשל בו” — ‏</a:t>
+            </a:r>
+            <a:pPr rtl="1" algn="r" indent="0" marL="0">
+              <a:spcAft>
+                <a:spcPts val="400"/>
+              </a:spcAft>
+              <a:buNone/>
+            </a:pPr>
+            <a:r>
+              <a:rPr lang="he-IL" altLang="en-US" sz="1400" b="1" dirty="0">
+                <a:solidFill>
+                  <a:schemeClr val="bg1"/>
+                </a:solidFill>
+              </a:rPr>
+              <a:t>‏„אם תרצה תתגבר עליו”‏</a:t>
+            </a:r>
+            <a:endParaRPr lang="he-IL" sz="1100" dirty="0"/>
           </a:p>
         </p:txBody>
       </p:sp>
@@ -4817,8 +5134,8 @@
         </p:nvSpPr>
         <p:spPr>
           <a:xfrm>
-            <a:off x="3931920" y="3703320"/>
-            <a:ext cx="4754880" cy="868680"/>
+            <a:off x="3931920" y="3840480"/>
+            <a:ext cx="4754880" cy="777240"/>
           </a:xfrm>
           <a:prstGeom prst="rect">
             <a:avLst/>
@@ -4834,14 +5151,14 @@
               <a:buNone/>
             </a:pPr>
             <a:r>
-              <a:rPr lang="he-IL" altLang="en-US" sz="1600" dirty="0">
+              <a:rPr lang="he-IL" altLang="en-US" sz="1500" dirty="0">
                 <a:solidFill>
                   <a:schemeClr val="accent3"/>
                 </a:solidFill>
               </a:rPr>
-              <a:t>היצר קיים ו„רובץ בפתח” — אבל ההחלטה נשארת בידי האדם. לפי רש״י, הכוח להתגבר נתון לנו — אם נרצה.‏</a:t>
-            </a:r>
-            <a:endParaRPr lang="he-IL" sz="1600" dirty="0"/>
+              <a:t>היצר קיים ו„רובץ בפתח”, והוא מושך כל הזמן. אבל ההחלטה נשארת בידי האדם: הכוח להתגבר נתון לנו — אם נרצה.‏</a:t>
+            </a:r>
+            <a:endParaRPr lang="he-IL" sz="1500" dirty="0"/>
           </a:p>
         </p:txBody>
       </p:sp>
@@ -4975,14 +5292,13 @@
         </p:nvPicPr>
         <p:blipFill>
           <a:blip r:embed="rId1"/>
-          <a:stretch>
-            <a:fillRect/>
-          </a:stretch>
+          <a:srcRect l="0" r="0" t="0" b="0"/>
+          <a:stretch/>
         </p:blipFill>
         <p:spPr>
           <a:xfrm>
             <a:off x="457200" y="1051560"/>
-            <a:ext cx="2926080" cy="3611880"/>
+            <a:ext cx="2377440" cy="3611880"/>
           </a:xfrm>
           <a:prstGeom prst="rect">
             <a:avLst/>
@@ -4997,12 +5313,12 @@
         </p:nvSpPr>
         <p:spPr>
           <a:xfrm>
-            <a:off x="6263640" y="1051560"/>
-            <a:ext cx="2423160" cy="2743200"/>
+            <a:off x="5989320" y="1051560"/>
+            <a:ext cx="2697480" cy="2788920"/>
           </a:xfrm>
           <a:prstGeom prst="roundRect">
             <a:avLst>
-              <a:gd name="adj" fmla="val 3774"/>
+              <a:gd name="adj" fmla="val 3390"/>
             </a:avLst>
           </a:prstGeom>
           <a:solidFill>
@@ -5019,7 +5335,7 @@
         </p:nvSpPr>
         <p:spPr>
           <a:xfrm>
-            <a:off x="8138160" y="1188720"/>
+            <a:off x="8138160" y="1161288"/>
             <a:ext cx="411480" cy="411480"/>
           </a:xfrm>
           <a:prstGeom prst="ellipse">
@@ -5047,7 +5363,7 @@
         </p:blipFill>
         <p:spPr>
           <a:xfrm>
-            <a:off x="8241030" y="1291590"/>
+            <a:off x="8241030" y="1264158"/>
             <a:ext cx="205740" cy="205740"/>
           </a:xfrm>
           <a:prstGeom prst="rect">
@@ -5063,8 +5379,8 @@
         </p:nvSpPr>
         <p:spPr>
           <a:xfrm>
-            <a:off x="6400800" y="1188720"/>
-            <a:ext cx="1664208" cy="411480"/>
+            <a:off x="6126480" y="1161288"/>
+            <a:ext cx="1938528" cy="411480"/>
           </a:xfrm>
           <a:prstGeom prst="rect">
             <a:avLst/>
@@ -5099,8 +5415,8 @@
         </p:nvSpPr>
         <p:spPr>
           <a:xfrm>
-            <a:off x="6400800" y="1737360"/>
-            <a:ext cx="2148840" cy="1965960"/>
+            <a:off x="6126480" y="1664208"/>
+            <a:ext cx="2423160" cy="2121408"/>
           </a:xfrm>
           <a:prstGeom prst="rect">
             <a:avLst/>
@@ -5114,7 +5430,7 @@
           <a:p>
             <a:pPr rtl="1" algn="r" indent="0" marL="0">
               <a:spcAft>
-                <a:spcPts val="800"/>
+                <a:spcPts val="500"/>
               </a:spcAft>
               <a:buNone/>
             </a:pPr>
@@ -5124,14 +5440,14 @@
                   <a:schemeClr val="tx2"/>
                 </a:solidFill>
               </a:rPr>
-              <a:t>קין הביא „מִפְּרִי הָאֲדָמָה” (ד׳, ג׳)‏</a:t>
+              <a:t>קין הביא „מִפְּרִי הָאֲדָמָה” (ד׳, ג׳)‏</a:t>
             </a:r>
             <a:endParaRPr lang="he-IL" sz="1400" dirty="0"/>
           </a:p>
           <a:p>
             <a:pPr rtl="1" algn="r" indent="0" marL="0">
               <a:spcAft>
-                <a:spcPts val="800"/>
+                <a:spcPts val="500"/>
               </a:spcAft>
               <a:buNone/>
             </a:pPr>
@@ -5141,14 +5457,14 @@
                   <a:schemeClr val="tx2"/>
                 </a:solidFill>
               </a:rPr>
-              <a:t>הבל הביא „מִבְּכֹרוֹת צֹאנוֹ וּמֵחֶלְבֵהֶן” (ד׳, ד׳)‏</a:t>
+              <a:t>הבל הביא „מִבְּכֹרוֹת צֹאנוֹ וּמֵחֶלְבֵהֶן” (ד׳, ד׳)‏</a:t>
             </a:r>
             <a:endParaRPr lang="he-IL" sz="1400" dirty="0"/>
           </a:p>
           <a:p>
             <a:pPr rtl="1" algn="r" indent="0" marL="0">
               <a:spcAft>
-                <a:spcPts val="800"/>
+                <a:spcPts val="500"/>
               </a:spcAft>
               <a:buNone/>
             </a:pPr>
@@ -5158,7 +5474,24 @@
                   <a:schemeClr val="tx2"/>
                 </a:solidFill>
               </a:rPr>
-              <a:t>ה׳ שעה אל הבל ומנחתו — ואל קין לא (ד׳, ד׳–ה׳)‏</a:t>
+              <a:t>ה׳ שעה אל הבל ומנחתו — ואל קין לא (ד׳, ד׳–ה׳)‏</a:t>
+            </a:r>
+            <a:endParaRPr lang="he-IL" sz="1400" dirty="0"/>
+          </a:p>
+          <a:p>
+            <a:pPr rtl="1" algn="r" indent="0" marL="0">
+              <a:spcAft>
+                <a:spcPts val="500"/>
+              </a:spcAft>
+              <a:buNone/>
+            </a:pPr>
+            <a:r>
+              <a:rPr lang="he-IL" altLang="en-US" sz="1400" dirty="0">
+                <a:solidFill>
+                  <a:schemeClr val="tx2"/>
+                </a:solidFill>
+              </a:rPr>
+              <a:t>ה׳ פונה לקין ושואל: „לָמָּה חָרָה לָךְ” (ד׳, ו׳)‏</a:t>
             </a:r>
             <a:endParaRPr lang="he-IL" sz="1400" dirty="0"/>
           </a:p>
@@ -5172,12 +5505,12 @@
         </p:nvSpPr>
         <p:spPr>
           <a:xfrm>
-            <a:off x="3657600" y="1051560"/>
-            <a:ext cx="2423160" cy="2743200"/>
+            <a:off x="3108960" y="1051560"/>
+            <a:ext cx="2697480" cy="2788920"/>
           </a:xfrm>
           <a:prstGeom prst="roundRect">
             <a:avLst>
-              <a:gd name="adj" fmla="val 3774"/>
+              <a:gd name="adj" fmla="val 3390"/>
             </a:avLst>
           </a:prstGeom>
           <a:solidFill>
@@ -5194,7 +5527,7 @@
         </p:nvSpPr>
         <p:spPr>
           <a:xfrm>
-            <a:off x="5532120" y="1188720"/>
+            <a:off x="5257800" y="1161288"/>
             <a:ext cx="411480" cy="411480"/>
           </a:xfrm>
           <a:prstGeom prst="ellipse">
@@ -5222,7 +5555,7 @@
         </p:blipFill>
         <p:spPr>
           <a:xfrm>
-            <a:off x="5634990" y="1291590"/>
+            <a:off x="5360670" y="1264158"/>
             <a:ext cx="205740" cy="205740"/>
           </a:xfrm>
           <a:prstGeom prst="rect">
@@ -5238,8 +5571,8 @@
         </p:nvSpPr>
         <p:spPr>
           <a:xfrm>
-            <a:off x="3794760" y="1188720"/>
-            <a:ext cx="1664208" cy="411480"/>
+            <a:off x="3246120" y="1161288"/>
+            <a:ext cx="1938528" cy="411480"/>
           </a:xfrm>
           <a:prstGeom prst="rect">
             <a:avLst/>
@@ -5274,8 +5607,8 @@
         </p:nvSpPr>
         <p:spPr>
           <a:xfrm>
-            <a:off x="3794760" y="1737360"/>
-            <a:ext cx="2148840" cy="1965960"/>
+            <a:off x="3246120" y="1664208"/>
+            <a:ext cx="2423160" cy="2121408"/>
           </a:xfrm>
           <a:prstGeom prst="rect">
             <a:avLst/>
@@ -5289,7 +5622,7 @@
           <a:p>
             <a:pPr rtl="1" algn="r" indent="0" marL="0">
               <a:spcAft>
-                <a:spcPts val="800"/>
+                <a:spcPts val="500"/>
               </a:spcAft>
               <a:buNone/>
             </a:pPr>
@@ -5299,14 +5632,14 @@
                   <a:schemeClr val="tx2"/>
                 </a:solidFill>
               </a:rPr>
-              <a:t>איכות: לפי רש״י, קין הביא „מן הגרוע” (רש״י ד׳, ג׳)‏</a:t>
+              <a:t>רש״י: קין הביא „מן הגרוע” (ד׳, ג׳)‏</a:t>
             </a:r>
             <a:endParaRPr lang="he-IL" sz="1400" dirty="0"/>
           </a:p>
           <a:p>
             <a:pPr rtl="1" algn="r" indent="0" marL="0">
               <a:spcAft>
-                <a:spcPts val="800"/>
+                <a:spcPts val="500"/>
               </a:spcAft>
               <a:buNone/>
             </a:pPr>
@@ -5316,6 +5649,23 @@
                   <a:schemeClr val="tx2"/>
                 </a:solidFill>
               </a:rPr>
+              <a:t>תנחומא: קין הביא „מן מותר מאכלו” — ממה שנשאר</a:t>
+            </a:r>
+            <a:endParaRPr lang="he-IL" sz="1400" dirty="0"/>
+          </a:p>
+          <a:p>
+            <a:pPr rtl="1" algn="r" indent="0" marL="0">
+              <a:spcAft>
+                <a:spcPts val="500"/>
+              </a:spcAft>
+              <a:buNone/>
+            </a:pPr>
+            <a:r>
+              <a:rPr lang="he-IL" altLang="en-US" sz="1400" dirty="0">
+                <a:solidFill>
+                  <a:schemeClr val="tx2"/>
+                </a:solidFill>
+              </a:rPr>
               <a:t>הבל בחר במובחר — „בכורות” ו„חלב”‏</a:t>
             </a:r>
             <a:endParaRPr lang="he-IL" sz="1400" dirty="0"/>
@@ -5323,7 +5673,7 @@
           <a:p>
             <a:pPr rtl="1" algn="r" indent="0" marL="0">
               <a:spcAft>
-                <a:spcPts val="800"/>
+                <a:spcPts val="500"/>
               </a:spcAft>
               <a:buNone/>
             </a:pPr>
@@ -5333,7 +5683,7 @@
                   <a:schemeClr val="tx2"/>
                 </a:solidFill>
               </a:rPr>
-              <a:t>הכוונה והלב שמאחורי הנתינה</a:t>
+              <a:t>ההבדל בכוונה ובלב שמאחורי הנתינה</a:t>
             </a:r>
             <a:endParaRPr lang="he-IL" sz="1400" dirty="0"/>
           </a:p>
@@ -5347,8 +5697,8 @@
         </p:nvSpPr>
         <p:spPr>
           <a:xfrm>
-            <a:off x="3657600" y="3977640"/>
-            <a:ext cx="5029200" cy="658368"/>
+            <a:off x="3108960" y="3977640"/>
+            <a:ext cx="5577840" cy="658368"/>
           </a:xfrm>
           <a:prstGeom prst="roundRect">
             <a:avLst>
@@ -5418,8 +5768,8 @@
         </p:nvSpPr>
         <p:spPr>
           <a:xfrm>
-            <a:off x="3794760" y="4005072"/>
-            <a:ext cx="4297680" cy="603504"/>
+            <a:off x="3246120" y="4005072"/>
+            <a:ext cx="4846320" cy="603504"/>
           </a:xfrm>
           <a:prstGeom prst="rect">
             <a:avLst/>
@@ -5440,7 +5790,7 @@
                   <a:schemeClr val="tx2"/>
                 </a:solidFill>
               </a:rPr>
-              <a:t>המקרא אינו מסביר במפורש מדוע מנחת קין לא התקבלה — כל הסבר הוא פרשנות.‏</a:t>
+              <a:t>המקרא אינו מסביר במפורש מדוע מנחת קין לא התקבלה. כל הסבר הוא פרשנות של חז״ל והמפרשים.‏</a:t>
             </a:r>
             <a:endParaRPr lang="he-IL" sz="1400" dirty="0"/>
           </a:p>
@@ -5676,7 +6026,7 @@
                   <a:schemeClr val="tx2"/>
                 </a:solidFill>
               </a:rPr>
-              <a:t>קין קם על הבל אחיו</a:t>
+              <a:t>קין קם על הבל אחיו — כעס שלא נעצר</a:t>
             </a:r>
             <a:pPr rtl="1" algn="r" indent="0" marL="0">
               <a:buNone/>
@@ -6043,14 +6393,13 @@
         </p:nvPicPr>
         <p:blipFill>
           <a:blip r:embed="rId4"/>
-          <a:stretch>
-            <a:fillRect/>
-          </a:stretch>
+          <a:srcRect l="0" r="0" t="0" b="0"/>
+          <a:stretch/>
         </p:blipFill>
         <p:spPr>
           <a:xfrm>
             <a:off x="457200" y="1051560"/>
-            <a:ext cx="3291840" cy="2240280"/>
+            <a:ext cx="3291840" cy="2011680"/>
           </a:xfrm>
           <a:prstGeom prst="rect">
             <a:avLst/>
@@ -6065,12 +6414,12 @@
         </p:nvSpPr>
         <p:spPr>
           <a:xfrm>
-            <a:off x="457200" y="3474720"/>
-            <a:ext cx="3291840" cy="1161288"/>
+            <a:off x="457200" y="3246120"/>
+            <a:ext cx="3291840" cy="1389888"/>
           </a:xfrm>
           <a:prstGeom prst="roundRect">
             <a:avLst>
-              <a:gd name="adj" fmla="val 7874"/>
+              <a:gd name="adj" fmla="val 6579"/>
             </a:avLst>
           </a:prstGeom>
           <a:solidFill>
@@ -6087,8 +6436,8 @@
         </p:nvSpPr>
         <p:spPr>
           <a:xfrm>
-            <a:off x="594360" y="3520440"/>
-            <a:ext cx="3017520" cy="1069848"/>
+            <a:off x="594360" y="3291840"/>
+            <a:ext cx="3017520" cy="1298448"/>
           </a:xfrm>
           <a:prstGeom prst="rect">
             <a:avLst/>
@@ -6115,7 +6464,7 @@
                 <a:ea typeface="Times New Roman" pitchFamily="34" charset="-122"/>
                 <a:cs typeface="Times New Roman" pitchFamily="34" charset="-120"/>
               </a:rPr>
-              <a:t>‏„גָּדוֹל עֲוֹנִי מִנְּשֹׂא” (ד׳, י״ג)‏</a:t>
+              <a:t>‏„גָּדוֹל עֲוֹנִי מִנְּשֹׂא” (ד׳, י״ג)‏</a:t>
             </a:r>
             <a:endParaRPr lang="he-IL" sz="1500" dirty="0"/>
           </a:p>
@@ -6132,7 +6481,24 @@
                   <a:schemeClr val="bg1"/>
                 </a:solidFill>
               </a:rPr>
-              <a:t>קין מכיר בכובד המעשה — וה׳ שם לו אות להגנה (ד׳, ט״ו)‏</a:t>
+              <a:t>קין מכיר בכובד המעשה — וה׳ שם לו אות להגנה (ד׳, ט״ו).‏</a:t>
+            </a:r>
+            <a:endParaRPr lang="he-IL" sz="1500" dirty="0"/>
+          </a:p>
+          <a:p>
+            <a:pPr rtl="1" algn="r" indent="0" marL="0">
+              <a:spcAft>
+                <a:spcPts val="400"/>
+              </a:spcAft>
+              <a:buNone/>
+            </a:pPr>
+            <a:r>
+              <a:rPr lang="he-IL" altLang="en-US" sz="1300" b="1" dirty="0">
+                <a:solidFill>
+                  <a:schemeClr val="accent1"/>
+                </a:solidFill>
+              </a:rPr>
+              <a:t>גם אחרי חטא יש מקום להכרה ולתיקון.‏</a:t>
             </a:r>
             <a:endParaRPr lang="he-IL" sz="1500" dirty="0"/>
           </a:p>
@@ -6293,8 +6659,8 @@
         </p:nvSpPr>
         <p:spPr>
           <a:xfrm>
-            <a:off x="457200" y="1051560"/>
-            <a:ext cx="4846320" cy="685800"/>
+            <a:off x="457200" y="1024128"/>
+            <a:ext cx="4937760" cy="914400"/>
           </a:xfrm>
           <a:prstGeom prst="rect">
             <a:avLst/>
@@ -6310,28 +6676,42 @@
               <a:buNone/>
             </a:pPr>
             <a:r>
-              <a:rPr lang="he-IL" altLang="en-US" sz="1500" dirty="0">
+              <a:rPr lang="he-IL" altLang="en-US" sz="1400" dirty="0">
                 <a:solidFill>
                   <a:schemeClr val="tx2"/>
                 </a:solidFill>
               </a:rPr>
-              <a:t>קין עונה בשאלה — כאילו אין לו קשר לאחיו (בראשית ד׳, ט׳).‏</a:t>
-            </a:r>
-            <a:endParaRPr lang="he-IL" sz="1500" dirty="0"/>
-          </a:p>
-          <a:p>
-            <a:pPr rtl="1" algn="r" indent="0" marL="0">
-              <a:buNone/>
-            </a:pPr>
-            <a:r>
-              <a:rPr lang="he-IL" altLang="en-US" sz="1500" b="1" dirty="0">
+              <a:t>קין עונה בשאלה — כאילו אין לו קשר לאחיו (בראשית ד׳, ט׳).‏</a:t>
+            </a:r>
+            <a:endParaRPr lang="he-IL" sz="1400" dirty="0"/>
+          </a:p>
+          <a:p>
+            <a:pPr rtl="1" algn="r" indent="0" marL="0">
+              <a:buNone/>
+            </a:pPr>
+            <a:r>
+              <a:rPr lang="he-IL" altLang="en-US" sz="1400" dirty="0">
                 <a:solidFill>
                   <a:schemeClr val="tx2"/>
                 </a:solidFill>
               </a:rPr>
+              <a:t>רש״י: „לשון תמה הוא” — קין משיב בשאלה מתריסה, ולא עונה.‏</a:t>
+            </a:r>
+            <a:endParaRPr lang="he-IL" sz="1400" dirty="0"/>
+          </a:p>
+          <a:p>
+            <a:pPr rtl="1" algn="r" indent="0" marL="0">
+              <a:buNone/>
+            </a:pPr>
+            <a:r>
+              <a:rPr lang="he-IL" altLang="en-US" sz="1400" b="1" dirty="0">
+                <a:solidFill>
+                  <a:schemeClr val="tx2"/>
+                </a:solidFill>
+              </a:rPr>
               <a:t>התורה מלמדת את ההפך: אנחנו קשורים זה לזה.‏</a:t>
             </a:r>
-            <a:endParaRPr lang="he-IL" sz="1500" dirty="0"/>
+            <a:endParaRPr lang="he-IL" sz="1400" dirty="0"/>
           </a:p>
         </p:txBody>
       </p:sp>
@@ -6343,8 +6723,8 @@
         </p:nvSpPr>
         <p:spPr>
           <a:xfrm>
-            <a:off x="3840480" y="1874520"/>
-            <a:ext cx="1463040" cy="1645920"/>
+            <a:off x="3840480" y="2057400"/>
+            <a:ext cx="1463040" cy="1508760"/>
           </a:xfrm>
           <a:prstGeom prst="roundRect">
             <a:avLst>
@@ -6365,8 +6745,8 @@
         </p:nvSpPr>
         <p:spPr>
           <a:xfrm>
-            <a:off x="4297680" y="1993392"/>
-            <a:ext cx="548640" cy="548640"/>
+            <a:off x="4343400" y="2130552"/>
+            <a:ext cx="457200" cy="457200"/>
           </a:xfrm>
           <a:prstGeom prst="ellipse">
             <a:avLst/>
@@ -6393,8 +6773,8 @@
         </p:blipFill>
         <p:spPr>
           <a:xfrm>
-            <a:off x="4434840" y="2130552"/>
-            <a:ext cx="274320" cy="274320"/>
+            <a:off x="4457700" y="2244852"/>
+            <a:ext cx="228600" cy="228600"/>
           </a:xfrm>
           <a:prstGeom prst="rect">
             <a:avLst/>
@@ -6409,8 +6789,8 @@
         </p:nvSpPr>
         <p:spPr>
           <a:xfrm>
-            <a:off x="3886200" y="2606040"/>
-            <a:ext cx="1371600" cy="320040"/>
+            <a:off x="3886200" y="2633472"/>
+            <a:ext cx="1371600" cy="292608"/>
           </a:xfrm>
           <a:prstGeom prst="rect">
             <a:avLst/>
@@ -6446,7 +6826,7 @@
         <p:spPr>
           <a:xfrm>
             <a:off x="3913632" y="2926080"/>
-            <a:ext cx="1316736" cy="530352"/>
+            <a:ext cx="1316736" cy="566928"/>
           </a:xfrm>
           <a:prstGeom prst="rect">
             <a:avLst/>
@@ -6467,7 +6847,7 @@
                   <a:schemeClr val="tx2"/>
                 </a:solidFill>
               </a:rPr>
-              <a:t>לא לעבור בשתיקה מול פגיעה</a:t>
+              <a:t>לא לעבור בשתיקה מול פגיעה, גם כשזה לא נוח</a:t>
             </a:r>
             <a:endParaRPr lang="he-IL" sz="1200" dirty="0"/>
           </a:p>
@@ -6481,8 +6861,8 @@
         </p:nvSpPr>
         <p:spPr>
           <a:xfrm>
-            <a:off x="2148840" y="1874520"/>
-            <a:ext cx="1463040" cy="1645920"/>
+            <a:off x="2148840" y="2057400"/>
+            <a:ext cx="1463040" cy="1508760"/>
           </a:xfrm>
           <a:prstGeom prst="roundRect">
             <a:avLst>
@@ -6503,8 +6883,8 @@
         </p:nvSpPr>
         <p:spPr>
           <a:xfrm>
-            <a:off x="2606040" y="1993392"/>
-            <a:ext cx="548640" cy="548640"/>
+            <a:off x="2651760" y="2130552"/>
+            <a:ext cx="457200" cy="457200"/>
           </a:xfrm>
           <a:prstGeom prst="ellipse">
             <a:avLst/>
@@ -6531,8 +6911,8 @@
         </p:blipFill>
         <p:spPr>
           <a:xfrm>
-            <a:off x="2743200" y="2130552"/>
-            <a:ext cx="274320" cy="274320"/>
+            <a:off x="2766060" y="2244852"/>
+            <a:ext cx="228600" cy="228600"/>
           </a:xfrm>
           <a:prstGeom prst="rect">
             <a:avLst/>
@@ -6547,8 +6927,8 @@
         </p:nvSpPr>
         <p:spPr>
           <a:xfrm>
-            <a:off x="2194560" y="2606040"/>
-            <a:ext cx="1371600" cy="320040"/>
+            <a:off x="2194560" y="2633472"/>
+            <a:ext cx="1371600" cy="292608"/>
           </a:xfrm>
           <a:prstGeom prst="rect">
             <a:avLst/>
@@ -6584,7 +6964,7 @@
         <p:spPr>
           <a:xfrm>
             <a:off x="2221992" y="2926080"/>
-            <a:ext cx="1316736" cy="530352"/>
+            <a:ext cx="1316736" cy="566928"/>
           </a:xfrm>
           <a:prstGeom prst="rect">
             <a:avLst/>
@@ -6605,7 +6985,7 @@
                   <a:schemeClr val="tx2"/>
                 </a:solidFill>
               </a:rPr>
-              <a:t>לשים לב למי שנמצא לידי</a:t>
+              <a:t>לשים לב למי שנמצא לידי ומרגיש לבד</a:t>
             </a:r>
             <a:endParaRPr lang="he-IL" sz="1200" dirty="0"/>
           </a:p>
@@ -6619,8 +6999,8 @@
         </p:nvSpPr>
         <p:spPr>
           <a:xfrm>
-            <a:off x="457200" y="1874520"/>
-            <a:ext cx="1463040" cy="1645920"/>
+            <a:off x="457200" y="2057400"/>
+            <a:ext cx="1463040" cy="1508760"/>
           </a:xfrm>
           <a:prstGeom prst="roundRect">
             <a:avLst>
@@ -6641,8 +7021,8 @@
         </p:nvSpPr>
         <p:spPr>
           <a:xfrm>
-            <a:off x="914400" y="1993392"/>
-            <a:ext cx="548640" cy="548640"/>
+            <a:off x="960120" y="2130552"/>
+            <a:ext cx="457200" cy="457200"/>
           </a:xfrm>
           <a:prstGeom prst="ellipse">
             <a:avLst/>
@@ -6669,8 +7049,8 @@
         </p:blipFill>
         <p:spPr>
           <a:xfrm>
-            <a:off x="1051560" y="2130552"/>
-            <a:ext cx="274320" cy="274320"/>
+            <a:off x="1074420" y="2244852"/>
+            <a:ext cx="228600" cy="228600"/>
           </a:xfrm>
           <a:prstGeom prst="rect">
             <a:avLst/>
@@ -6685,8 +7065,8 @@
         </p:nvSpPr>
         <p:spPr>
           <a:xfrm>
-            <a:off x="502920" y="2606040"/>
-            <a:ext cx="1371600" cy="320040"/>
+            <a:off x="502920" y="2633472"/>
+            <a:ext cx="1371600" cy="292608"/>
           </a:xfrm>
           <a:prstGeom prst="rect">
             <a:avLst/>
@@ -6722,7 +7102,7 @@
         <p:spPr>
           <a:xfrm>
             <a:off x="530352" y="2926080"/>
-            <a:ext cx="1316736" cy="530352"/>
+            <a:ext cx="1316736" cy="566928"/>
           </a:xfrm>
           <a:prstGeom prst="rect">
             <a:avLst/>
@@ -6743,7 +7123,7 @@
                   <a:schemeClr val="tx2"/>
                 </a:solidFill>
               </a:rPr>
-              <a:t>ליצור מקום בטוח לכולם</a:t>
+              <a:t>ליצור מקום בטוח, שבו אף אחד לא נשאר מאחור</a:t>
             </a:r>
             <a:endParaRPr lang="he-IL" sz="1200" dirty="0"/>
           </a:p>
@@ -6757,12 +7137,12 @@
         </p:nvSpPr>
         <p:spPr>
           <a:xfrm>
-            <a:off x="457200" y="3703320"/>
-            <a:ext cx="4846320" cy="914400"/>
+            <a:off x="457200" y="3730752"/>
+            <a:ext cx="4846320" cy="886968"/>
           </a:xfrm>
           <a:prstGeom prst="roundRect">
             <a:avLst>
-              <a:gd name="adj" fmla="val 12000"/>
+              <a:gd name="adj" fmla="val 12371"/>
             </a:avLst>
           </a:prstGeom>
           <a:solidFill>
@@ -6786,8 +7166,8 @@
         </p:nvSpPr>
         <p:spPr>
           <a:xfrm>
-            <a:off x="548640" y="3703320"/>
-            <a:ext cx="4663440" cy="914400"/>
+            <a:off x="548640" y="3730752"/>
+            <a:ext cx="4663440" cy="886968"/>
           </a:xfrm>
           <a:prstGeom prst="rect">
             <a:avLst/>
@@ -6962,7 +7342,7 @@
         <p:spPr>
           <a:xfrm>
             <a:off x="457200" y="1051560"/>
-            <a:ext cx="2560320" cy="3611880"/>
+            <a:ext cx="2560320" cy="3593592"/>
           </a:xfrm>
           <a:prstGeom prst="rect">
             <a:avLst/>
@@ -6978,11 +7358,11 @@
         <p:spPr>
           <a:xfrm>
             <a:off x="6080760" y="1051560"/>
-            <a:ext cx="2606040" cy="1874520"/>
+            <a:ext cx="2606040" cy="1719072"/>
           </a:xfrm>
           <a:prstGeom prst="roundRect">
             <a:avLst>
-              <a:gd name="adj" fmla="val 4878"/>
+              <a:gd name="adj" fmla="val 5319"/>
             </a:avLst>
           </a:prstGeom>
           <a:solidFill>
@@ -7079,8 +7459,8 @@
         </p:nvSpPr>
         <p:spPr>
           <a:xfrm>
-            <a:off x="6217920" y="1627632"/>
-            <a:ext cx="2331720" cy="1005840"/>
+            <a:off x="6217920" y="1591056"/>
+            <a:ext cx="2331720" cy="914400"/>
           </a:xfrm>
           <a:prstGeom prst="rect">
             <a:avLst/>
@@ -7203,7 +7583,7 @@
         </p:nvSpPr>
         <p:spPr>
           <a:xfrm>
-            <a:off x="6217920" y="2651760"/>
+            <a:off x="6217920" y="2514600"/>
             <a:ext cx="2331720" cy="201168"/>
           </a:xfrm>
           <a:prstGeom prst="rect">
@@ -7240,11 +7620,11 @@
         <p:spPr>
           <a:xfrm>
             <a:off x="3291840" y="1051560"/>
-            <a:ext cx="2606040" cy="1874520"/>
+            <a:ext cx="2606040" cy="1719072"/>
           </a:xfrm>
           <a:prstGeom prst="roundRect">
             <a:avLst>
-              <a:gd name="adj" fmla="val 4878"/>
+              <a:gd name="adj" fmla="val 5319"/>
             </a:avLst>
           </a:prstGeom>
           <a:solidFill>
@@ -7341,8 +7721,8 @@
         </p:nvSpPr>
         <p:spPr>
           <a:xfrm>
-            <a:off x="3429000" y="1627632"/>
-            <a:ext cx="2331720" cy="1005840"/>
+            <a:off x="3429000" y="1591056"/>
+            <a:ext cx="2331720" cy="914400"/>
           </a:xfrm>
           <a:prstGeom prst="rect">
             <a:avLst/>
@@ -7465,7 +7845,7 @@
         </p:nvSpPr>
         <p:spPr>
           <a:xfrm>
-            <a:off x="3429000" y="2651760"/>
+            <a:off x="3429000" y="2514600"/>
             <a:ext cx="2331720" cy="201168"/>
           </a:xfrm>
           <a:prstGeom prst="rect">
@@ -7501,7 +7881,54 @@
         </p:nvSpPr>
         <p:spPr>
           <a:xfrm>
-            <a:off x="3291840" y="3035808"/>
+            <a:off x="3291840" y="2834640"/>
+            <a:ext cx="5394960" cy="292608"/>
+          </a:xfrm>
+          <a:prstGeom prst="rect">
+            <a:avLst/>
+          </a:prstGeom>
+          <a:noFill/>
+          <a:ln/>
+        </p:spPr>
+        <p:txBody>
+          <a:bodyPr wrap="square" lIns="0" tIns="0" rIns="0" bIns="0" rtlCol="0" anchor="ctr"/>
+          <a:lstStyle/>
+          <a:p>
+            <a:pPr rtl="1" algn="r" indent="0" marL="0">
+              <a:buNone/>
+            </a:pPr>
+            <a:r>
+              <a:rPr lang="he-IL" altLang="en-US" sz="1300" b="1" dirty="0">
+                <a:solidFill>
+                  <a:schemeClr val="tx2"/>
+                </a:solidFill>
+              </a:rPr>
+              <a:t>רש״י (ד׳, ט׳): ‏</a:t>
+            </a:r>
+            <a:pPr rtl="1" algn="r" indent="0" marL="0">
+              <a:buNone/>
+            </a:pPr>
+            <a:r>
+              <a:rPr lang="he-IL" altLang="en-US" sz="1300" dirty="0">
+                <a:solidFill>
+                  <a:schemeClr val="tx2"/>
+                </a:solidFill>
+              </a:rPr>
+              <a:t>ה׳ שאל „אי הבל אחיך” כדי לתת לקין פתח — „אולי ישוב ויאמר: אני הרגתיו”.‏</a:t>
+            </a:r>
+            <a:endParaRPr lang="he-IL" sz="1300" dirty="0"/>
+          </a:p>
+        </p:txBody>
+      </p:sp>
+      <p:sp>
+        <p:nvSpPr>
+          <p:cNvPr id="17" name="Text 12"/>
+          <p:cNvSpPr txBox="1"/>
+          <p:nvPr/>
+        </p:nvSpPr>
+        <p:spPr>
+          <a:xfrm>
+            <a:off x="3291840" y="3172968"/>
             <a:ext cx="5394960" cy="256032"/>
           </a:xfrm>
           <a:prstGeom prst="rect">
@@ -7523,7 +7950,7 @@
                   <a:schemeClr val="accent1"/>
                 </a:solidFill>
               </a:rPr>
-              <a:t>שלושה צעדים, לפי הרמב״ם (הלכות תשובה א׳, א׳)‏</a:t>
+              <a:t>שלושה צעדים, לפי הרמב״ם (הלכות תשובה א׳, א׳)‏</a:t>
             </a:r>
             <a:endParaRPr lang="he-IL" sz="1200" dirty="0"/>
           </a:p>
@@ -7531,18 +7958,18 @@
       </p:sp>
       <p:sp>
         <p:nvSpPr>
-          <p:cNvPr id="17" name="Step 1"/>
+          <p:cNvPr id="18" name="Step 1"/>
           <p:cNvSpPr/>
           <p:nvPr/>
         </p:nvSpPr>
         <p:spPr>
           <a:xfrm>
-            <a:off x="6949440" y="3364992"/>
-            <a:ext cx="1737360" cy="1280160"/>
+            <a:off x="6949440" y="3474720"/>
+            <a:ext cx="1737360" cy="1170432"/>
           </a:xfrm>
           <a:prstGeom prst="roundRect">
             <a:avLst>
-              <a:gd name="adj" fmla="val 7143"/>
+              <a:gd name="adj" fmla="val 7813"/>
             </a:avLst>
           </a:prstGeom>
           <a:solidFill>
@@ -7553,14 +7980,14 @@
       </p:sp>
       <p:sp>
         <p:nvSpPr>
-          <p:cNvPr id="18" name="Step 1 badge"/>
+          <p:cNvPr id="19" name="Step 1 badge"/>
           <p:cNvSpPr/>
           <p:nvPr/>
         </p:nvSpPr>
         <p:spPr>
           <a:xfrm>
-            <a:off x="7635240" y="3456432"/>
-            <a:ext cx="365760" cy="365760"/>
+            <a:off x="7662672" y="3538728"/>
+            <a:ext cx="310896" cy="310896"/>
           </a:xfrm>
           <a:prstGeom prst="ellipse">
             <a:avLst/>
@@ -7573,50 +8000,14 @@
       </p:sp>
       <p:sp>
         <p:nvSpPr>
-          <p:cNvPr id="19" name="Text 14"/>
-          <p:cNvSpPr txBox="1"/>
-          <p:nvPr/>
-        </p:nvSpPr>
-        <p:spPr>
-          <a:xfrm>
-            <a:off x="7635240" y="3456432"/>
-            <a:ext cx="365760" cy="365760"/>
-          </a:xfrm>
-          <a:prstGeom prst="rect">
-            <a:avLst/>
-          </a:prstGeom>
-          <a:noFill/>
-          <a:ln/>
-        </p:spPr>
-        <p:txBody>
-          <a:bodyPr wrap="square" lIns="0" tIns="0" rIns="0" bIns="0" rtlCol="0" anchor="ctr"/>
-          <a:lstStyle/>
-          <a:p>
-            <a:pPr rtl="1" algn="ctr" indent="0" marL="0">
-              <a:buNone/>
-            </a:pPr>
-            <a:r>
-              <a:rPr lang="he-IL" altLang="en-US" sz="1300" b="1" dirty="0">
-                <a:solidFill>
-                  <a:schemeClr val="tx2"/>
-                </a:solidFill>
-              </a:rPr>
-              <a:t>‏1‏</a:t>
-            </a:r>
-            <a:endParaRPr lang="he-IL" sz="1300" dirty="0"/>
-          </a:p>
-        </p:txBody>
-      </p:sp>
-      <p:sp>
-        <p:nvSpPr>
           <p:cNvPr id="20" name="Text 15"/>
           <p:cNvSpPr txBox="1"/>
           <p:nvPr/>
         </p:nvSpPr>
         <p:spPr>
           <a:xfrm>
-            <a:off x="6995160" y="3858768"/>
-            <a:ext cx="1645920" cy="329184"/>
+            <a:off x="7662672" y="3538728"/>
+            <a:ext cx="310896" cy="310896"/>
           </a:xfrm>
           <a:prstGeom prst="rect">
             <a:avLst/>
@@ -7632,14 +8023,14 @@
               <a:buNone/>
             </a:pPr>
             <a:r>
-              <a:rPr lang="he-IL" altLang="en-US" sz="1600" b="1" dirty="0">
-                <a:solidFill>
-                  <a:schemeClr val="bg1"/>
-                </a:solidFill>
-              </a:rPr>
-              <a:t>להודות</a:t>
-            </a:r>
-            <a:endParaRPr lang="he-IL" sz="1600" dirty="0"/>
+              <a:rPr lang="he-IL" altLang="en-US" sz="1300" b="1" dirty="0">
+                <a:solidFill>
+                  <a:schemeClr val="tx2"/>
+                </a:solidFill>
+              </a:rPr>
+              <a:t>‏1‏</a:t>
+            </a:r>
+            <a:endParaRPr lang="he-IL" sz="1300" dirty="0"/>
           </a:p>
         </p:txBody>
       </p:sp>
@@ -7651,8 +8042,44 @@
         </p:nvSpPr>
         <p:spPr>
           <a:xfrm>
+            <a:off x="6995160" y="3877056"/>
+            <a:ext cx="1645920" cy="310896"/>
+          </a:xfrm>
+          <a:prstGeom prst="rect">
+            <a:avLst/>
+          </a:prstGeom>
+          <a:noFill/>
+          <a:ln/>
+        </p:spPr>
+        <p:txBody>
+          <a:bodyPr wrap="square" lIns="0" tIns="0" rIns="0" bIns="0" rtlCol="0" anchor="ctr"/>
+          <a:lstStyle/>
+          <a:p>
+            <a:pPr rtl="1" algn="ctr" indent="0" marL="0">
+              <a:buNone/>
+            </a:pPr>
+            <a:r>
+              <a:rPr lang="he-IL" altLang="en-US" sz="1600" b="1" dirty="0">
+                <a:solidFill>
+                  <a:schemeClr val="bg1"/>
+                </a:solidFill>
+              </a:rPr>
+              <a:t>להודות</a:t>
+            </a:r>
+            <a:endParaRPr lang="he-IL" sz="1600" dirty="0"/>
+          </a:p>
+        </p:txBody>
+      </p:sp>
+      <p:sp>
+        <p:nvSpPr>
+          <p:cNvPr id="22" name="Text 17"/>
+          <p:cNvSpPr txBox="1"/>
+          <p:nvPr/>
+        </p:nvSpPr>
+        <p:spPr>
+          <a:xfrm>
             <a:off x="7022592" y="4187952"/>
-            <a:ext cx="1591056" cy="411480"/>
+            <a:ext cx="1591056" cy="420624"/>
           </a:xfrm>
           <a:prstGeom prst="rect">
             <a:avLst/>
@@ -7681,18 +8108,18 @@
       </p:sp>
       <p:sp>
         <p:nvSpPr>
-          <p:cNvPr id="22" name="Step 2"/>
+          <p:cNvPr id="23" name="Step 2"/>
           <p:cNvSpPr/>
           <p:nvPr/>
         </p:nvSpPr>
         <p:spPr>
           <a:xfrm>
-            <a:off x="5120640" y="3364992"/>
-            <a:ext cx="1737360" cy="1280160"/>
+            <a:off x="5120640" y="3474720"/>
+            <a:ext cx="1737360" cy="1170432"/>
           </a:xfrm>
           <a:prstGeom prst="roundRect">
             <a:avLst>
-              <a:gd name="adj" fmla="val 7143"/>
+              <a:gd name="adj" fmla="val 7813"/>
             </a:avLst>
           </a:prstGeom>
           <a:solidFill>
@@ -7703,14 +8130,14 @@
       </p:sp>
       <p:sp>
         <p:nvSpPr>
-          <p:cNvPr id="23" name="Step 2 badge"/>
+          <p:cNvPr id="24" name="Step 2 badge"/>
           <p:cNvSpPr/>
           <p:nvPr/>
         </p:nvSpPr>
         <p:spPr>
           <a:xfrm>
-            <a:off x="5806440" y="3456432"/>
-            <a:ext cx="365760" cy="365760"/>
+            <a:off x="5833872" y="3538728"/>
+            <a:ext cx="310896" cy="310896"/>
           </a:xfrm>
           <a:prstGeom prst="ellipse">
             <a:avLst/>
@@ -7723,50 +8150,14 @@
       </p:sp>
       <p:sp>
         <p:nvSpPr>
-          <p:cNvPr id="24" name="Text 19"/>
-          <p:cNvSpPr txBox="1"/>
-          <p:nvPr/>
-        </p:nvSpPr>
-        <p:spPr>
-          <a:xfrm>
-            <a:off x="5806440" y="3456432"/>
-            <a:ext cx="365760" cy="365760"/>
-          </a:xfrm>
-          <a:prstGeom prst="rect">
-            <a:avLst/>
-          </a:prstGeom>
-          <a:noFill/>
-          <a:ln/>
-        </p:spPr>
-        <p:txBody>
-          <a:bodyPr wrap="square" lIns="0" tIns="0" rIns="0" bIns="0" rtlCol="0" anchor="ctr"/>
-          <a:lstStyle/>
-          <a:p>
-            <a:pPr rtl="1" algn="ctr" indent="0" marL="0">
-              <a:buNone/>
-            </a:pPr>
-            <a:r>
-              <a:rPr lang="he-IL" altLang="en-US" sz="1300" b="1" dirty="0">
-                <a:solidFill>
-                  <a:schemeClr val="tx2"/>
-                </a:solidFill>
-              </a:rPr>
-              <a:t>‏2‏</a:t>
-            </a:r>
-            <a:endParaRPr lang="he-IL" sz="1300" dirty="0"/>
-          </a:p>
-        </p:txBody>
-      </p:sp>
-      <p:sp>
-        <p:nvSpPr>
           <p:cNvPr id="25" name="Text 20"/>
           <p:cNvSpPr txBox="1"/>
           <p:nvPr/>
         </p:nvSpPr>
         <p:spPr>
           <a:xfrm>
-            <a:off x="5166360" y="3858768"/>
-            <a:ext cx="1645920" cy="329184"/>
+            <a:off x="5833872" y="3538728"/>
+            <a:ext cx="310896" cy="310896"/>
           </a:xfrm>
           <a:prstGeom prst="rect">
             <a:avLst/>
@@ -7782,14 +8173,14 @@
               <a:buNone/>
             </a:pPr>
             <a:r>
-              <a:rPr lang="he-IL" altLang="en-US" sz="1600" b="1" dirty="0">
-                <a:solidFill>
-                  <a:schemeClr val="bg1"/>
-                </a:solidFill>
-              </a:rPr>
-              <a:t>להתחרט</a:t>
-            </a:r>
-            <a:endParaRPr lang="he-IL" sz="1600" dirty="0"/>
+              <a:rPr lang="he-IL" altLang="en-US" sz="1300" b="1" dirty="0">
+                <a:solidFill>
+                  <a:schemeClr val="tx2"/>
+                </a:solidFill>
+              </a:rPr>
+              <a:t>‏2‏</a:t>
+            </a:r>
+            <a:endParaRPr lang="he-IL" sz="1300" dirty="0"/>
           </a:p>
         </p:txBody>
       </p:sp>
@@ -7801,8 +8192,44 @@
         </p:nvSpPr>
         <p:spPr>
           <a:xfrm>
+            <a:off x="5166360" y="3877056"/>
+            <a:ext cx="1645920" cy="310896"/>
+          </a:xfrm>
+          <a:prstGeom prst="rect">
+            <a:avLst/>
+          </a:prstGeom>
+          <a:noFill/>
+          <a:ln/>
+        </p:spPr>
+        <p:txBody>
+          <a:bodyPr wrap="square" lIns="0" tIns="0" rIns="0" bIns="0" rtlCol="0" anchor="ctr"/>
+          <a:lstStyle/>
+          <a:p>
+            <a:pPr rtl="1" algn="ctr" indent="0" marL="0">
+              <a:buNone/>
+            </a:pPr>
+            <a:r>
+              <a:rPr lang="he-IL" altLang="en-US" sz="1600" b="1" dirty="0">
+                <a:solidFill>
+                  <a:schemeClr val="bg1"/>
+                </a:solidFill>
+              </a:rPr>
+              <a:t>להתחרט</a:t>
+            </a:r>
+            <a:endParaRPr lang="he-IL" sz="1600" dirty="0"/>
+          </a:p>
+        </p:txBody>
+      </p:sp>
+      <p:sp>
+        <p:nvSpPr>
+          <p:cNvPr id="27" name="Text 22"/>
+          <p:cNvSpPr txBox="1"/>
+          <p:nvPr/>
+        </p:nvSpPr>
+        <p:spPr>
+          <a:xfrm>
             <a:off x="5193792" y="4187952"/>
-            <a:ext cx="1591056" cy="411480"/>
+            <a:ext cx="1591056" cy="420624"/>
           </a:xfrm>
           <a:prstGeom prst="rect">
             <a:avLst/>
@@ -7831,18 +8258,18 @@
       </p:sp>
       <p:sp>
         <p:nvSpPr>
-          <p:cNvPr id="27" name="Step 3"/>
+          <p:cNvPr id="28" name="Step 3"/>
           <p:cNvSpPr/>
           <p:nvPr/>
         </p:nvSpPr>
         <p:spPr>
           <a:xfrm>
-            <a:off x="3291840" y="3364992"/>
-            <a:ext cx="1737360" cy="1280160"/>
+            <a:off x="3291840" y="3474720"/>
+            <a:ext cx="1737360" cy="1170432"/>
           </a:xfrm>
           <a:prstGeom prst="roundRect">
             <a:avLst>
-              <a:gd name="adj" fmla="val 7143"/>
+              <a:gd name="adj" fmla="val 7813"/>
             </a:avLst>
           </a:prstGeom>
           <a:solidFill>
@@ -7853,14 +8280,14 @@
       </p:sp>
       <p:sp>
         <p:nvSpPr>
-          <p:cNvPr id="28" name="Step 3 badge"/>
+          <p:cNvPr id="29" name="Step 3 badge"/>
           <p:cNvSpPr/>
           <p:nvPr/>
         </p:nvSpPr>
         <p:spPr>
           <a:xfrm>
-            <a:off x="3977640" y="3456432"/>
-            <a:ext cx="365760" cy="365760"/>
+            <a:off x="4005072" y="3538728"/>
+            <a:ext cx="310896" cy="310896"/>
           </a:xfrm>
           <a:prstGeom prst="ellipse">
             <a:avLst/>
@@ -7873,50 +8300,14 @@
       </p:sp>
       <p:sp>
         <p:nvSpPr>
-          <p:cNvPr id="29" name="Text 24"/>
-          <p:cNvSpPr txBox="1"/>
-          <p:nvPr/>
-        </p:nvSpPr>
-        <p:spPr>
-          <a:xfrm>
-            <a:off x="3977640" y="3456432"/>
-            <a:ext cx="365760" cy="365760"/>
-          </a:xfrm>
-          <a:prstGeom prst="rect">
-            <a:avLst/>
-          </a:prstGeom>
-          <a:noFill/>
-          <a:ln/>
-        </p:spPr>
-        <p:txBody>
-          <a:bodyPr wrap="square" lIns="0" tIns="0" rIns="0" bIns="0" rtlCol="0" anchor="ctr"/>
-          <a:lstStyle/>
-          <a:p>
-            <a:pPr rtl="1" algn="ctr" indent="0" marL="0">
-              <a:buNone/>
-            </a:pPr>
-            <a:r>
-              <a:rPr lang="he-IL" altLang="en-US" sz="1300" b="1" dirty="0">
-                <a:solidFill>
-                  <a:schemeClr val="tx2"/>
-                </a:solidFill>
-              </a:rPr>
-              <a:t>‏3‏</a:t>
-            </a:r>
-            <a:endParaRPr lang="he-IL" sz="1300" dirty="0"/>
-          </a:p>
-        </p:txBody>
-      </p:sp>
-      <p:sp>
-        <p:nvSpPr>
           <p:cNvPr id="30" name="Text 25"/>
           <p:cNvSpPr txBox="1"/>
           <p:nvPr/>
         </p:nvSpPr>
         <p:spPr>
           <a:xfrm>
-            <a:off x="3337560" y="3858768"/>
-            <a:ext cx="1645920" cy="329184"/>
+            <a:off x="4005072" y="3538728"/>
+            <a:ext cx="310896" cy="310896"/>
           </a:xfrm>
           <a:prstGeom prst="rect">
             <a:avLst/>
@@ -7932,14 +8323,14 @@
               <a:buNone/>
             </a:pPr>
             <a:r>
-              <a:rPr lang="he-IL" altLang="en-US" sz="1600" b="1" dirty="0">
-                <a:solidFill>
-                  <a:schemeClr val="bg1"/>
-                </a:solidFill>
-              </a:rPr>
-              <a:t>לתקן</a:t>
-            </a:r>
-            <a:endParaRPr lang="he-IL" sz="1600" dirty="0"/>
+              <a:rPr lang="he-IL" altLang="en-US" sz="1300" b="1" dirty="0">
+                <a:solidFill>
+                  <a:schemeClr val="tx2"/>
+                </a:solidFill>
+              </a:rPr>
+              <a:t>‏3‏</a:t>
+            </a:r>
+            <a:endParaRPr lang="he-IL" sz="1300" dirty="0"/>
           </a:p>
         </p:txBody>
       </p:sp>
@@ -7951,8 +8342,44 @@
         </p:nvSpPr>
         <p:spPr>
           <a:xfrm>
+            <a:off x="3337560" y="3877056"/>
+            <a:ext cx="1645920" cy="310896"/>
+          </a:xfrm>
+          <a:prstGeom prst="rect">
+            <a:avLst/>
+          </a:prstGeom>
+          <a:noFill/>
+          <a:ln/>
+        </p:spPr>
+        <p:txBody>
+          <a:bodyPr wrap="square" lIns="0" tIns="0" rIns="0" bIns="0" rtlCol="0" anchor="ctr"/>
+          <a:lstStyle/>
+          <a:p>
+            <a:pPr rtl="1" algn="ctr" indent="0" marL="0">
+              <a:buNone/>
+            </a:pPr>
+            <a:r>
+              <a:rPr lang="he-IL" altLang="en-US" sz="1600" b="1" dirty="0">
+                <a:solidFill>
+                  <a:schemeClr val="bg1"/>
+                </a:solidFill>
+              </a:rPr>
+              <a:t>לתקן</a:t>
+            </a:r>
+            <a:endParaRPr lang="he-IL" sz="1600" dirty="0"/>
+          </a:p>
+        </p:txBody>
+      </p:sp>
+      <p:sp>
+        <p:nvSpPr>
+          <p:cNvPr id="32" name="Text 27"/>
+          <p:cNvSpPr txBox="1"/>
+          <p:nvPr/>
+        </p:nvSpPr>
+        <p:spPr>
+          <a:xfrm>
             <a:off x="3364992" y="4187952"/>
-            <a:ext cx="1591056" cy="411480"/>
+            <a:ext cx="1591056" cy="420624"/>
           </a:xfrm>
           <a:prstGeom prst="rect">
             <a:avLst/>
@@ -8470,18 +8897,65 @@
       </p:sp>
       <p:sp>
         <p:nvSpPr>
-          <p:cNvPr id="15" name="Response card 1"/>
+          <p:cNvPr id="15" name="Text 12"/>
+          <p:cNvSpPr txBox="1"/>
+          <p:nvPr/>
+        </p:nvSpPr>
+        <p:spPr>
+          <a:xfrm>
+            <a:off x="3657600" y="2926080"/>
+            <a:ext cx="5029200" cy="274320"/>
+          </a:xfrm>
+          <a:prstGeom prst="rect">
+            <a:avLst/>
+          </a:prstGeom>
+          <a:noFill/>
+          <a:ln/>
+        </p:spPr>
+        <p:txBody>
+          <a:bodyPr wrap="square" lIns="0" tIns="0" rIns="0" bIns="0" rtlCol="0" anchor="ctr"/>
+          <a:lstStyle/>
+          <a:p>
+            <a:pPr rtl="1" algn="r" indent="0" marL="0">
+              <a:buNone/>
+            </a:pPr>
+            <a:r>
+              <a:rPr lang="he-IL" altLang="en-US" sz="1300" b="1" dirty="0">
+                <a:solidFill>
+                  <a:schemeClr val="accent1"/>
+                </a:solidFill>
+              </a:rPr>
+              <a:t>‏„למשול בחטא” = ‏</a:t>
+            </a:r>
+            <a:pPr rtl="1" algn="r" indent="0" marL="0">
+              <a:buNone/>
+            </a:pPr>
+            <a:r>
+              <a:rPr lang="he-IL" altLang="en-US" sz="1300" dirty="0">
+                <a:solidFill>
+                  <a:schemeClr val="tx2"/>
+                </a:solidFill>
+              </a:rPr>
+              <a:t>לא להעלים את הרגש, אלא לבחור מה עושים איתו.‏</a:t>
+            </a:r>
+            <a:endParaRPr lang="he-IL" sz="1300" dirty="0"/>
+          </a:p>
+        </p:txBody>
+      </p:sp>
+      <p:sp>
+        <p:nvSpPr>
+          <p:cNvPr id="16" name="Response card 1"/>
           <p:cNvSpPr/>
           <p:nvPr/>
         </p:nvSpPr>
         <p:spPr>
           <a:xfrm>
-            <a:off x="6126480" y="3108960"/>
-            <a:ext cx="2560320" cy="1508760"/>
+            <a:off x="6126480" y="3291840"/>
+            <a:ext cx="2560320" cy="1344168"/>
           </a:xfrm>
           <a:prstGeom prst="roundRect">
             <a:avLst>
-              <a:gd name="adj" fmla="val 6061"/>
+              <a:gd name="adj" fmla="val 6803"/>
             </a:avLst>
           </a:prstGeom>
           <a:solidFill>
@@ -8492,14 +8966,14 @@
       </p:sp>
       <p:sp>
         <p:nvSpPr>
-          <p:cNvPr id="16" name="Response 1 circle"/>
+          <p:cNvPr id="17" name="Response 1 circle"/>
           <p:cNvSpPr/>
           <p:nvPr/>
         </p:nvSpPr>
         <p:spPr>
           <a:xfrm>
-            <a:off x="7132320" y="3218688"/>
-            <a:ext cx="548640" cy="548640"/>
+            <a:off x="7178040" y="3364992"/>
+            <a:ext cx="457200" cy="457200"/>
           </a:xfrm>
           <a:prstGeom prst="ellipse">
             <a:avLst/>
@@ -8512,7 +8986,7 @@
       </p:sp>
       <p:pic>
         <p:nvPicPr>
-          <p:cNvPr id="17" name="Response 1 icon" descr="preencoded.png">    </p:cNvPr>
+          <p:cNvPr id="18" name="Response 1 icon" descr="preencoded.png">    </p:cNvPr>
           <p:cNvPicPr>
             <a:picLocks noChangeAspect="1"/>
           </p:cNvPicPr>
@@ -8526,50 +9000,14 @@
         </p:blipFill>
         <p:spPr>
           <a:xfrm>
-            <a:off x="7269480" y="3355848"/>
-            <a:ext cx="274320" cy="274320"/>
+            <a:off x="7292340" y="3479292"/>
+            <a:ext cx="228600" cy="228600"/>
           </a:xfrm>
           <a:prstGeom prst="rect">
             <a:avLst/>
           </a:prstGeom>
         </p:spPr>
       </p:pic>
-      <p:sp>
-        <p:nvSpPr>
-          <p:cNvPr id="18" name="Text 14"/>
-          <p:cNvSpPr txBox="1"/>
-          <p:nvPr/>
-        </p:nvSpPr>
-        <p:spPr>
-          <a:xfrm>
-            <a:off x="6217920" y="3822192"/>
-            <a:ext cx="2377440" cy="365760"/>
-          </a:xfrm>
-          <a:prstGeom prst="rect">
-            <a:avLst/>
-          </a:prstGeom>
-          <a:noFill/>
-          <a:ln/>
-        </p:spPr>
-        <p:txBody>
-          <a:bodyPr wrap="square" lIns="0" tIns="0" rIns="0" bIns="0" rtlCol="0" anchor="ctr"/>
-          <a:lstStyle/>
-          <a:p>
-            <a:pPr rtl="1" algn="ctr" indent="0" marL="0">
-              <a:buNone/>
-            </a:pPr>
-            <a:r>
-              <a:rPr lang="he-IL" altLang="en-US" sz="1600" b="1" dirty="0">
-                <a:solidFill>
-                  <a:schemeClr val="tx2"/>
-                </a:solidFill>
-              </a:rPr>
-              <a:t>להתפרץ</a:t>
-            </a:r>
-            <a:endParaRPr lang="he-IL" sz="1600" dirty="0"/>
-          </a:p>
-        </p:txBody>
-      </p:sp>
       <p:sp>
         <p:nvSpPr>
           <p:cNvPr id="19" name="Text 15"/>
@@ -8578,8 +9016,8 @@
         </p:nvSpPr>
         <p:spPr>
           <a:xfrm>
-            <a:off x="6217920" y="4187952"/>
-            <a:ext cx="2377440" cy="320040"/>
+            <a:off x="6217920" y="3858768"/>
+            <a:ext cx="2377440" cy="329184"/>
           </a:xfrm>
           <a:prstGeom prst="rect">
             <a:avLst/>
@@ -8595,12 +9033,48 @@
               <a:buNone/>
             </a:pPr>
             <a:r>
+              <a:rPr lang="he-IL" altLang="en-US" sz="1600" b="1" dirty="0">
+                <a:solidFill>
+                  <a:schemeClr val="tx2"/>
+                </a:solidFill>
+              </a:rPr>
+              <a:t>להתפרץ</a:t>
+            </a:r>
+            <a:endParaRPr lang="he-IL" sz="1600" dirty="0"/>
+          </a:p>
+        </p:txBody>
+      </p:sp>
+      <p:sp>
+        <p:nvSpPr>
+          <p:cNvPr id="20" name="Text 16"/>
+          <p:cNvSpPr txBox="1"/>
+          <p:nvPr/>
+        </p:nvSpPr>
+        <p:spPr>
+          <a:xfrm>
+            <a:off x="6217920" y="4206240"/>
+            <a:ext cx="2377440" cy="365760"/>
+          </a:xfrm>
+          <a:prstGeom prst="rect">
+            <a:avLst/>
+          </a:prstGeom>
+          <a:noFill/>
+          <a:ln/>
+        </p:spPr>
+        <p:txBody>
+          <a:bodyPr wrap="square" lIns="0" tIns="0" rIns="0" bIns="0" rtlCol="0" anchor="ctr"/>
+          <a:lstStyle/>
+          <a:p>
+            <a:pPr rtl="1" algn="ctr" indent="0" marL="0">
+              <a:buNone/>
+            </a:pPr>
+            <a:r>
               <a:rPr lang="he-IL" altLang="en-US" sz="1200" dirty="0">
                 <a:solidFill>
                   <a:schemeClr val="accent6"/>
                 </a:solidFill>
               </a:rPr>
-              <a:t>מה יקרה אחר כך?‏</a:t>
+              <a:t>מה יקרה אחר כך? מי ייפגע?‏</a:t>
             </a:r>
             <a:endParaRPr lang="he-IL" sz="1200" dirty="0"/>
           </a:p>
@@ -8608,18 +9082,18 @@
       </p:sp>
       <p:sp>
         <p:nvSpPr>
-          <p:cNvPr id="20" name="Response card 2"/>
+          <p:cNvPr id="21" name="Response card 2"/>
           <p:cNvSpPr/>
           <p:nvPr/>
         </p:nvSpPr>
         <p:spPr>
           <a:xfrm>
-            <a:off x="3291840" y="3108960"/>
-            <a:ext cx="2560320" cy="1508760"/>
+            <a:off x="3291840" y="3291840"/>
+            <a:ext cx="2560320" cy="1344168"/>
           </a:xfrm>
           <a:prstGeom prst="roundRect">
             <a:avLst>
-              <a:gd name="adj" fmla="val 6061"/>
+              <a:gd name="adj" fmla="val 6803"/>
             </a:avLst>
           </a:prstGeom>
           <a:solidFill>
@@ -8630,14 +9104,14 @@
       </p:sp>
       <p:sp>
         <p:nvSpPr>
-          <p:cNvPr id="21" name="Response 2 circle"/>
+          <p:cNvPr id="22" name="Response 2 circle"/>
           <p:cNvSpPr/>
           <p:nvPr/>
         </p:nvSpPr>
         <p:spPr>
           <a:xfrm>
-            <a:off x="4297680" y="3218688"/>
-            <a:ext cx="548640" cy="548640"/>
+            <a:off x="4343400" y="3364992"/>
+            <a:ext cx="457200" cy="457200"/>
           </a:xfrm>
           <a:prstGeom prst="ellipse">
             <a:avLst/>
@@ -8650,7 +9124,7 @@
       </p:sp>
       <p:pic>
         <p:nvPicPr>
-          <p:cNvPr id="22" name="Response 2 icon" descr="preencoded.png">    </p:cNvPr>
+          <p:cNvPr id="23" name="Response 2 icon" descr="preencoded.png">    </p:cNvPr>
           <p:cNvPicPr>
             <a:picLocks noChangeAspect="1"/>
           </p:cNvPicPr>
@@ -8664,50 +9138,14 @@
         </p:blipFill>
         <p:spPr>
           <a:xfrm>
-            <a:off x="4434840" y="3355848"/>
-            <a:ext cx="274320" cy="274320"/>
+            <a:off x="4457700" y="3479292"/>
+            <a:ext cx="228600" cy="228600"/>
           </a:xfrm>
           <a:prstGeom prst="rect">
             <a:avLst/>
           </a:prstGeom>
         </p:spPr>
       </p:pic>
-      <p:sp>
-        <p:nvSpPr>
-          <p:cNvPr id="23" name="Text 18"/>
-          <p:cNvSpPr txBox="1"/>
-          <p:nvPr/>
-        </p:nvSpPr>
-        <p:spPr>
-          <a:xfrm>
-            <a:off x="3383280" y="3822192"/>
-            <a:ext cx="2377440" cy="365760"/>
-          </a:xfrm>
-          <a:prstGeom prst="rect">
-            <a:avLst/>
-          </a:prstGeom>
-          <a:noFill/>
-          <a:ln/>
-        </p:spPr>
-        <p:txBody>
-          <a:bodyPr wrap="square" lIns="0" tIns="0" rIns="0" bIns="0" rtlCol="0" anchor="ctr"/>
-          <a:lstStyle/>
-          <a:p>
-            <a:pPr rtl="1" algn="ctr" indent="0" marL="0">
-              <a:buNone/>
-            </a:pPr>
-            <a:r>
-              <a:rPr lang="he-IL" altLang="en-US" sz="1600" b="1" dirty="0">
-                <a:solidFill>
-                  <a:schemeClr val="tx2"/>
-                </a:solidFill>
-              </a:rPr>
-              <a:t>להתרחק ולחשוב</a:t>
-            </a:r>
-            <a:endParaRPr lang="he-IL" sz="1600" dirty="0"/>
-          </a:p>
-        </p:txBody>
-      </p:sp>
       <p:sp>
         <p:nvSpPr>
           <p:cNvPr id="24" name="Text 19"/>
@@ -8716,8 +9154,8 @@
         </p:nvSpPr>
         <p:spPr>
           <a:xfrm>
-            <a:off x="3383280" y="4187952"/>
-            <a:ext cx="2377440" cy="320040"/>
+            <a:off x="3383280" y="3858768"/>
+            <a:ext cx="2377440" cy="329184"/>
           </a:xfrm>
           <a:prstGeom prst="rect">
             <a:avLst/>
@@ -8733,12 +9171,48 @@
               <a:buNone/>
             </a:pPr>
             <a:r>
+              <a:rPr lang="he-IL" altLang="en-US" sz="1600" b="1" dirty="0">
+                <a:solidFill>
+                  <a:schemeClr val="tx2"/>
+                </a:solidFill>
+              </a:rPr>
+              <a:t>להתרחק ולחשוב</a:t>
+            </a:r>
+            <a:endParaRPr lang="he-IL" sz="1600" dirty="0"/>
+          </a:p>
+        </p:txBody>
+      </p:sp>
+      <p:sp>
+        <p:nvSpPr>
+          <p:cNvPr id="25" name="Text 20"/>
+          <p:cNvSpPr txBox="1"/>
+          <p:nvPr/>
+        </p:nvSpPr>
+        <p:spPr>
+          <a:xfrm>
+            <a:off x="3383280" y="4206240"/>
+            <a:ext cx="2377440" cy="365760"/>
+          </a:xfrm>
+          <a:prstGeom prst="rect">
+            <a:avLst/>
+          </a:prstGeom>
+          <a:noFill/>
+          <a:ln/>
+        </p:spPr>
+        <p:txBody>
+          <a:bodyPr wrap="square" lIns="0" tIns="0" rIns="0" bIns="0" rtlCol="0" anchor="ctr"/>
+          <a:lstStyle/>
+          <a:p>
+            <a:pPr rtl="1" algn="ctr" indent="0" marL="0">
+              <a:buNone/>
+            </a:pPr>
+            <a:r>
               <a:rPr lang="he-IL" altLang="en-US" sz="1200" dirty="0">
                 <a:solidFill>
                   <a:schemeClr val="accent6"/>
                 </a:solidFill>
               </a:rPr>
-              <a:t>איך זה עוזר לי להירגע?‏</a:t>
+              <a:t>איך זה עוזר לי להירגע ולבחור?‏</a:t>
             </a:r>
             <a:endParaRPr lang="he-IL" sz="1200" dirty="0"/>
           </a:p>
@@ -8746,18 +9220,18 @@
       </p:sp>
       <p:sp>
         <p:nvSpPr>
-          <p:cNvPr id="25" name="Response card 3"/>
+          <p:cNvPr id="26" name="Response card 3"/>
           <p:cNvSpPr/>
           <p:nvPr/>
         </p:nvSpPr>
         <p:spPr>
           <a:xfrm>
-            <a:off x="457200" y="3108960"/>
-            <a:ext cx="2560320" cy="1508760"/>
+            <a:off x="457200" y="3291840"/>
+            <a:ext cx="2560320" cy="1344168"/>
           </a:xfrm>
           <a:prstGeom prst="roundRect">
             <a:avLst>
-              <a:gd name="adj" fmla="val 6061"/>
+              <a:gd name="adj" fmla="val 6803"/>
             </a:avLst>
           </a:prstGeom>
           <a:solidFill>
@@ -8773,14 +9247,14 @@
       </p:sp>
       <p:sp>
         <p:nvSpPr>
-          <p:cNvPr id="26" name="Response 3 circle"/>
+          <p:cNvPr id="27" name="Response 3 circle"/>
           <p:cNvSpPr/>
           <p:nvPr/>
         </p:nvSpPr>
         <p:spPr>
           <a:xfrm>
-            <a:off x="1463040" y="3218688"/>
-            <a:ext cx="548640" cy="548640"/>
+            <a:off x="1508760" y="3364992"/>
+            <a:ext cx="457200" cy="457200"/>
           </a:xfrm>
           <a:prstGeom prst="ellipse">
             <a:avLst/>
@@ -8793,7 +9267,7 @@
       </p:sp>
       <p:pic>
         <p:nvPicPr>
-          <p:cNvPr id="27" name="Response 3 icon" descr="preencoded.png">    </p:cNvPr>
+          <p:cNvPr id="28" name="Response 3 icon" descr="preencoded.png">    </p:cNvPr>
           <p:cNvPicPr>
             <a:picLocks noChangeAspect="1"/>
           </p:cNvPicPr>
@@ -8807,50 +9281,14 @@
         </p:blipFill>
         <p:spPr>
           <a:xfrm>
-            <a:off x="1600200" y="3355848"/>
-            <a:ext cx="274320" cy="274320"/>
+            <a:off x="1623060" y="3479292"/>
+            <a:ext cx="228600" cy="228600"/>
           </a:xfrm>
           <a:prstGeom prst="rect">
             <a:avLst/>
           </a:prstGeom>
         </p:spPr>
       </p:pic>
-      <p:sp>
-        <p:nvSpPr>
-          <p:cNvPr id="28" name="Text 22"/>
-          <p:cNvSpPr txBox="1"/>
-          <p:nvPr/>
-        </p:nvSpPr>
-        <p:spPr>
-          <a:xfrm>
-            <a:off x="548640" y="3822192"/>
-            <a:ext cx="2377440" cy="365760"/>
-          </a:xfrm>
-          <a:prstGeom prst="rect">
-            <a:avLst/>
-          </a:prstGeom>
-          <a:noFill/>
-          <a:ln/>
-        </p:spPr>
-        <p:txBody>
-          <a:bodyPr wrap="square" lIns="0" tIns="0" rIns="0" bIns="0" rtlCol="0" anchor="ctr"/>
-          <a:lstStyle/>
-          <a:p>
-            <a:pPr rtl="1" algn="ctr" indent="0" marL="0">
-              <a:buNone/>
-            </a:pPr>
-            <a:r>
-              <a:rPr lang="he-IL" altLang="en-US" sz="1600" b="1" dirty="0">
-                <a:solidFill>
-                  <a:schemeClr val="tx2"/>
-                </a:solidFill>
-              </a:rPr>
-              <a:t>לפרגן ולדבר על הרגש</a:t>
-            </a:r>
-            <a:endParaRPr lang="he-IL" sz="1600" dirty="0"/>
-          </a:p>
-        </p:txBody>
-      </p:sp>
       <p:sp>
         <p:nvSpPr>
           <p:cNvPr id="29" name="Text 23"/>
@@ -8859,8 +9297,8 @@
         </p:nvSpPr>
         <p:spPr>
           <a:xfrm>
-            <a:off x="548640" y="4187952"/>
-            <a:ext cx="2377440" cy="320040"/>
+            <a:off x="548640" y="3858768"/>
+            <a:ext cx="2377440" cy="329184"/>
           </a:xfrm>
           <a:prstGeom prst="rect">
             <a:avLst/>
@@ -8876,12 +9314,48 @@
               <a:buNone/>
             </a:pPr>
             <a:r>
+              <a:rPr lang="he-IL" altLang="en-US" sz="1600" b="1" dirty="0">
+                <a:solidFill>
+                  <a:schemeClr val="tx2"/>
+                </a:solidFill>
+              </a:rPr>
+              <a:t>לפרגן ולדבר על הרגש</a:t>
+            </a:r>
+            <a:endParaRPr lang="he-IL" sz="1600" dirty="0"/>
+          </a:p>
+        </p:txBody>
+      </p:sp>
+      <p:sp>
+        <p:nvSpPr>
+          <p:cNvPr id="30" name="Text 24"/>
+          <p:cNvSpPr txBox="1"/>
+          <p:nvPr/>
+        </p:nvSpPr>
+        <p:spPr>
+          <a:xfrm>
+            <a:off x="548640" y="4206240"/>
+            <a:ext cx="2377440" cy="365760"/>
+          </a:xfrm>
+          <a:prstGeom prst="rect">
+            <a:avLst/>
+          </a:prstGeom>
+          <a:noFill/>
+          <a:ln/>
+        </p:spPr>
+        <p:txBody>
+          <a:bodyPr wrap="square" lIns="0" tIns="0" rIns="0" bIns="0" rtlCol="0" anchor="ctr"/>
+          <a:lstStyle/>
+          <a:p>
+            <a:pPr rtl="1" algn="ctr" indent="0" marL="0">
+              <a:buNone/>
+            </a:pPr>
+            <a:r>
               <a:rPr lang="he-IL" altLang="en-US" sz="1200" dirty="0">
                 <a:solidFill>
                   <a:schemeClr val="accent6"/>
                 </a:solidFill>
               </a:rPr>
-              <a:t>מה זה עושה לחברות?‏</a:t>
+              <a:t>מה זה עושה לי ולחברות?‏</a:t>
             </a:r>
             <a:endParaRPr lang="he-IL" sz="1200" dirty="0"/>
           </a:p>

</xml_diff>